<commit_message>
Add report diagrams and refresh progress
</commit_message>
<xml_diff>
--- a/report/src/src.pptx
+++ b/report/src/src.pptx
@@ -8,8 +8,13 @@
     <p:sldId id="256" r:id="rId2"/>
     <p:sldId id="257" r:id="rId3"/>
     <p:sldId id="260" r:id="rId4"/>
-    <p:sldId id="258" r:id="rId5"/>
-    <p:sldId id="259" r:id="rId6"/>
+    <p:sldId id="264" r:id="rId5"/>
+    <p:sldId id="265" r:id="rId6"/>
+    <p:sldId id="258" r:id="rId7"/>
+    <p:sldId id="261" r:id="rId8"/>
+    <p:sldId id="262" r:id="rId9"/>
+    <p:sldId id="263" r:id="rId10"/>
+    <p:sldId id="259" r:id="rId11"/>
   </p:sldIdLst>
   <p:sldSz cx="9144000" cy="5143500" type="screen16x9"/>
   <p:notesSz cx="6858000" cy="9144000"/>
@@ -108,6 +113,11 @@
       </a:defRPr>
     </a:lvl9pPr>
   </p:defaultTextStyle>
+  <p:extLst>
+    <p:ext uri="{EFAFB233-063F-42B5-8137-9DF3F51BA10A}">
+      <p15:sldGuideLst xmlns:p15="http://schemas.microsoft.com/office/powerpoint/2012/main"/>
+    </p:ext>
+  </p:extLst>
 </p:presentation>
 </file>
 
@@ -3816,6 +3826,42 @@
 </p:sld>
 </file>
 
+<file path=ppt/slides/slide10.xml><?xml version="1.0" encoding="utf-8"?>
+<p:sld xmlns:a="http://schemas.openxmlformats.org/drawingml/2006/main" xmlns:r="http://schemas.openxmlformats.org/officeDocument/2006/relationships" xmlns:p="http://schemas.openxmlformats.org/presentationml/2006/main">
+  <p:cSld>
+    <p:spTree>
+      <p:nvGrpSpPr>
+        <p:cNvPr id="1" name="">
+          <a:extLst>
+            <a:ext uri="{FF2B5EF4-FFF2-40B4-BE49-F238E27FC236}">
+              <a16:creationId xmlns:a16="http://schemas.microsoft.com/office/drawing/2014/main" id="{43A60FA7-66B9-687B-16BE-83478BC4D874}"/>
+            </a:ext>
+          </a:extLst>
+        </p:cNvPr>
+        <p:cNvGrpSpPr/>
+        <p:nvPr/>
+      </p:nvGrpSpPr>
+      <p:grpSpPr>
+        <a:xfrm>
+          <a:off x="0" y="0"/>
+          <a:ext cx="0" cy="0"/>
+          <a:chOff x="0" y="0"/>
+          <a:chExt cx="0" cy="0"/>
+        </a:xfrm>
+      </p:grpSpPr>
+    </p:spTree>
+    <p:extLst>
+      <p:ext uri="{BB962C8B-B14F-4D97-AF65-F5344CB8AC3E}">
+        <p14:creationId xmlns:p14="http://schemas.microsoft.com/office/powerpoint/2010/main" val="3653332716"/>
+      </p:ext>
+    </p:extLst>
+  </p:cSld>
+  <p:clrMapOvr>
+    <a:masterClrMapping/>
+  </p:clrMapOvr>
+</p:sld>
+</file>
+
 <file path=ppt/slides/slide2.xml><?xml version="1.0" encoding="utf-8"?>
 <p:sld xmlns:a="http://schemas.openxmlformats.org/drawingml/2006/main" xmlns:r="http://schemas.openxmlformats.org/officeDocument/2006/relationships" xmlns:p="http://schemas.openxmlformats.org/presentationml/2006/main">
   <p:cSld>
@@ -6570,6 +6616,3461 @@
         <p:cNvPr id="1" name="">
           <a:extLst>
             <a:ext uri="{FF2B5EF4-FFF2-40B4-BE49-F238E27FC236}">
+              <a16:creationId xmlns:a16="http://schemas.microsoft.com/office/drawing/2014/main" id="{E77B8F88-7E9F-7AEC-4FDB-8AAC5AF222F4}"/>
+            </a:ext>
+          </a:extLst>
+        </p:cNvPr>
+        <p:cNvGrpSpPr/>
+        <p:nvPr/>
+      </p:nvGrpSpPr>
+      <p:grpSpPr>
+        <a:xfrm>
+          <a:off x="0" y="0"/>
+          <a:ext cx="0" cy="0"/>
+          <a:chOff x="0" y="0"/>
+          <a:chExt cx="0" cy="0"/>
+        </a:xfrm>
+      </p:grpSpPr>
+      <p:sp>
+        <p:nvSpPr>
+          <p:cNvPr id="4" name="流程图: 过程 3">
+            <a:extLst>
+              <a:ext uri="{FF2B5EF4-FFF2-40B4-BE49-F238E27FC236}">
+                <a16:creationId xmlns:a16="http://schemas.microsoft.com/office/drawing/2014/main" id="{2058943B-8232-E4A7-BB43-C025C4BFB99C}"/>
+              </a:ext>
+            </a:extLst>
+          </p:cNvPr>
+          <p:cNvSpPr/>
+          <p:nvPr/>
+        </p:nvSpPr>
+        <p:spPr>
+          <a:xfrm>
+            <a:off x="1602363" y="957719"/>
+            <a:ext cx="1120078" cy="248209"/>
+          </a:xfrm>
+          <a:prstGeom prst="flowChartProcess">
+            <a:avLst/>
+          </a:prstGeom>
+          <a:solidFill>
+            <a:schemeClr val="accent1">
+              <a:lumMod val="60000"/>
+              <a:lumOff val="40000"/>
+            </a:schemeClr>
+          </a:solidFill>
+        </p:spPr>
+        <p:style>
+          <a:lnRef idx="2">
+            <a:schemeClr val="accent1">
+              <a:shade val="15000"/>
+            </a:schemeClr>
+          </a:lnRef>
+          <a:fillRef idx="1">
+            <a:schemeClr val="accent1"/>
+          </a:fillRef>
+          <a:effectRef idx="0">
+            <a:schemeClr val="accent1"/>
+          </a:effectRef>
+          <a:fontRef idx="minor">
+            <a:schemeClr val="lt1"/>
+          </a:fontRef>
+        </p:style>
+        <p:txBody>
+          <a:bodyPr rtlCol="0" anchor="ctr"/>
+          <a:lstStyle/>
+          <a:p>
+            <a:pPr algn="ctr"/>
+            <a:r>
+              <a:rPr lang="en-US" altLang="zh-CN" sz="1013" b="1" dirty="0">
+                <a:solidFill>
+                  <a:schemeClr val="tx1"/>
+                </a:solidFill>
+              </a:rPr>
+              <a:t>ROS2</a:t>
+            </a:r>
+            <a:r>
+              <a:rPr lang="zh-CN" altLang="en-US" sz="1013" b="1" dirty="0">
+                <a:solidFill>
+                  <a:schemeClr val="tx1"/>
+                </a:solidFill>
+              </a:rPr>
+              <a:t>发现</a:t>
+            </a:r>
+            <a:r>
+              <a:rPr lang="en-US" altLang="zh-CN" sz="1013" b="1" dirty="0">
+                <a:solidFill>
+                  <a:schemeClr val="tx1"/>
+                </a:solidFill>
+              </a:rPr>
+              <a:t>/CLI</a:t>
+            </a:r>
+            <a:endParaRPr lang="zh-CN" altLang="en-US" sz="1013" b="1" dirty="0">
+              <a:solidFill>
+                <a:schemeClr val="tx1"/>
+              </a:solidFill>
+            </a:endParaRPr>
+          </a:p>
+        </p:txBody>
+      </p:sp>
+      <p:sp>
+        <p:nvSpPr>
+          <p:cNvPr id="5" name="流程图: 过程 4">
+            <a:extLst>
+              <a:ext uri="{FF2B5EF4-FFF2-40B4-BE49-F238E27FC236}">
+                <a16:creationId xmlns:a16="http://schemas.microsoft.com/office/drawing/2014/main" id="{F5E7F9AF-D918-D52E-8CA9-FA322412B369}"/>
+              </a:ext>
+            </a:extLst>
+          </p:cNvPr>
+          <p:cNvSpPr/>
+          <p:nvPr/>
+        </p:nvSpPr>
+        <p:spPr>
+          <a:xfrm>
+            <a:off x="3386388" y="946166"/>
+            <a:ext cx="1185612" cy="259761"/>
+          </a:xfrm>
+          <a:prstGeom prst="flowChartProcess">
+            <a:avLst/>
+          </a:prstGeom>
+          <a:solidFill>
+            <a:schemeClr val="accent2">
+              <a:lumMod val="40000"/>
+              <a:lumOff val="60000"/>
+            </a:schemeClr>
+          </a:solidFill>
+        </p:spPr>
+        <p:style>
+          <a:lnRef idx="2">
+            <a:schemeClr val="accent1">
+              <a:shade val="15000"/>
+            </a:schemeClr>
+          </a:lnRef>
+          <a:fillRef idx="1">
+            <a:schemeClr val="accent1"/>
+          </a:fillRef>
+          <a:effectRef idx="0">
+            <a:schemeClr val="accent1"/>
+          </a:effectRef>
+          <a:fontRef idx="minor">
+            <a:schemeClr val="lt1"/>
+          </a:fontRef>
+        </p:style>
+        <p:txBody>
+          <a:bodyPr rtlCol="0" anchor="ctr"/>
+          <a:lstStyle/>
+          <a:p>
+            <a:pPr algn="ctr"/>
+            <a:r>
+              <a:rPr lang="en-US" altLang="zh-CN" sz="1013" b="1" dirty="0">
+                <a:solidFill>
+                  <a:schemeClr val="tx1"/>
+                </a:solidFill>
+              </a:rPr>
+              <a:t>/</a:t>
+            </a:r>
+            <a:r>
+              <a:rPr lang="en-US" altLang="zh-CN" sz="1013" b="1" dirty="0" err="1">
+                <a:solidFill>
+                  <a:schemeClr val="tx1"/>
+                </a:solidFill>
+              </a:rPr>
+              <a:t>joint_states</a:t>
+            </a:r>
+            <a:endParaRPr lang="en-US" altLang="zh-CN" sz="1013" b="1" dirty="0">
+              <a:solidFill>
+                <a:schemeClr val="tx1"/>
+              </a:solidFill>
+            </a:endParaRPr>
+          </a:p>
+        </p:txBody>
+      </p:sp>
+      <p:sp>
+        <p:nvSpPr>
+          <p:cNvPr id="20" name="流程图: 过程 19">
+            <a:extLst>
+              <a:ext uri="{FF2B5EF4-FFF2-40B4-BE49-F238E27FC236}">
+                <a16:creationId xmlns:a16="http://schemas.microsoft.com/office/drawing/2014/main" id="{C7452DF6-34A0-7E87-4245-2F8BA59BC3D4}"/>
+              </a:ext>
+            </a:extLst>
+          </p:cNvPr>
+          <p:cNvSpPr/>
+          <p:nvPr/>
+        </p:nvSpPr>
+        <p:spPr>
+          <a:xfrm>
+            <a:off x="5054741" y="963497"/>
+            <a:ext cx="1926857" cy="248209"/>
+          </a:xfrm>
+          <a:prstGeom prst="flowChartProcess">
+            <a:avLst/>
+          </a:prstGeom>
+          <a:solidFill>
+            <a:schemeClr val="accent1">
+              <a:lumMod val="60000"/>
+              <a:lumOff val="40000"/>
+            </a:schemeClr>
+          </a:solidFill>
+        </p:spPr>
+        <p:style>
+          <a:lnRef idx="2">
+            <a:schemeClr val="accent1">
+              <a:shade val="15000"/>
+            </a:schemeClr>
+          </a:lnRef>
+          <a:fillRef idx="1">
+            <a:schemeClr val="accent1"/>
+          </a:fillRef>
+          <a:effectRef idx="0">
+            <a:schemeClr val="accent1"/>
+          </a:effectRef>
+          <a:fontRef idx="minor">
+            <a:schemeClr val="lt1"/>
+          </a:fontRef>
+        </p:style>
+        <p:txBody>
+          <a:bodyPr rtlCol="0" anchor="ctr"/>
+          <a:lstStyle/>
+          <a:p>
+            <a:pPr algn="ctr"/>
+            <a:r>
+              <a:rPr lang="en-US" altLang="zh-CN" sz="1013" b="1" dirty="0" err="1">
+                <a:solidFill>
+                  <a:schemeClr val="tx1"/>
+                </a:solidFill>
+              </a:rPr>
+              <a:t>robot_state_publisher</a:t>
+            </a:r>
+            <a:endParaRPr lang="zh-CN" altLang="en-US" sz="1013" b="1" dirty="0">
+              <a:solidFill>
+                <a:schemeClr val="tx1"/>
+              </a:solidFill>
+            </a:endParaRPr>
+          </a:p>
+        </p:txBody>
+      </p:sp>
+      <p:sp>
+        <p:nvSpPr>
+          <p:cNvPr id="21" name="流程图: 过程 20">
+            <a:extLst>
+              <a:ext uri="{FF2B5EF4-FFF2-40B4-BE49-F238E27FC236}">
+                <a16:creationId xmlns:a16="http://schemas.microsoft.com/office/drawing/2014/main" id="{B3D28377-D476-0534-12FA-09289282C1EE}"/>
+              </a:ext>
+            </a:extLst>
+          </p:cNvPr>
+          <p:cNvSpPr/>
+          <p:nvPr/>
+        </p:nvSpPr>
+        <p:spPr>
+          <a:xfrm>
+            <a:off x="413168" y="951942"/>
+            <a:ext cx="836152" cy="259761"/>
+          </a:xfrm>
+          <a:prstGeom prst="flowChartProcess">
+            <a:avLst/>
+          </a:prstGeom>
+          <a:solidFill>
+            <a:schemeClr val="accent3">
+              <a:lumMod val="40000"/>
+              <a:lumOff val="60000"/>
+            </a:schemeClr>
+          </a:solidFill>
+        </p:spPr>
+        <p:style>
+          <a:lnRef idx="2">
+            <a:schemeClr val="accent1">
+              <a:shade val="15000"/>
+            </a:schemeClr>
+          </a:lnRef>
+          <a:fillRef idx="1">
+            <a:schemeClr val="accent1"/>
+          </a:fillRef>
+          <a:effectRef idx="0">
+            <a:schemeClr val="accent1"/>
+          </a:effectRef>
+          <a:fontRef idx="minor">
+            <a:schemeClr val="lt1"/>
+          </a:fontRef>
+        </p:style>
+        <p:txBody>
+          <a:bodyPr rtlCol="0" anchor="ctr"/>
+          <a:lstStyle/>
+          <a:p>
+            <a:pPr algn="ctr"/>
+            <a:r>
+              <a:rPr lang="zh-CN" altLang="en-US" sz="1013" b="1" dirty="0">
+                <a:solidFill>
+                  <a:schemeClr val="tx1"/>
+                </a:solidFill>
+              </a:rPr>
+              <a:t>攻击者</a:t>
+            </a:r>
+            <a:endParaRPr lang="en-US" altLang="zh-CN" sz="1013" b="1" dirty="0">
+              <a:solidFill>
+                <a:schemeClr val="tx1"/>
+              </a:solidFill>
+            </a:endParaRPr>
+          </a:p>
+        </p:txBody>
+      </p:sp>
+      <p:sp>
+        <p:nvSpPr>
+          <p:cNvPr id="22" name="流程图: 过程 21">
+            <a:extLst>
+              <a:ext uri="{FF2B5EF4-FFF2-40B4-BE49-F238E27FC236}">
+                <a16:creationId xmlns:a16="http://schemas.microsoft.com/office/drawing/2014/main" id="{91EF29F2-A9E4-547B-8656-D2B3ED92C50F}"/>
+              </a:ext>
+            </a:extLst>
+          </p:cNvPr>
+          <p:cNvSpPr/>
+          <p:nvPr/>
+        </p:nvSpPr>
+        <p:spPr>
+          <a:xfrm>
+            <a:off x="7464339" y="963496"/>
+            <a:ext cx="1185611" cy="248209"/>
+          </a:xfrm>
+          <a:prstGeom prst="flowChartProcess">
+            <a:avLst/>
+          </a:prstGeom>
+          <a:solidFill>
+            <a:schemeClr val="accent1">
+              <a:lumMod val="60000"/>
+              <a:lumOff val="40000"/>
+            </a:schemeClr>
+          </a:solidFill>
+        </p:spPr>
+        <p:style>
+          <a:lnRef idx="2">
+            <a:schemeClr val="accent1">
+              <a:shade val="15000"/>
+            </a:schemeClr>
+          </a:lnRef>
+          <a:fillRef idx="1">
+            <a:schemeClr val="accent1"/>
+          </a:fillRef>
+          <a:effectRef idx="0">
+            <a:schemeClr val="accent1"/>
+          </a:effectRef>
+          <a:fontRef idx="minor">
+            <a:schemeClr val="lt1"/>
+          </a:fontRef>
+        </p:style>
+        <p:txBody>
+          <a:bodyPr rtlCol="0" anchor="ctr"/>
+          <a:lstStyle/>
+          <a:p>
+            <a:pPr algn="ctr"/>
+            <a:r>
+              <a:rPr lang="en-US" altLang="zh-CN" sz="1013" b="1" dirty="0">
+                <a:solidFill>
+                  <a:schemeClr val="tx1"/>
+                </a:solidFill>
+              </a:rPr>
+              <a:t>RViz</a:t>
+            </a:r>
+            <a:endParaRPr lang="zh-CN" altLang="en-US" sz="1013" b="1" dirty="0">
+              <a:solidFill>
+                <a:schemeClr val="tx1"/>
+              </a:solidFill>
+            </a:endParaRPr>
+          </a:p>
+        </p:txBody>
+      </p:sp>
+      <p:cxnSp>
+        <p:nvCxnSpPr>
+          <p:cNvPr id="10" name="直接连接符 9">
+            <a:extLst>
+              <a:ext uri="{FF2B5EF4-FFF2-40B4-BE49-F238E27FC236}">
+                <a16:creationId xmlns:a16="http://schemas.microsoft.com/office/drawing/2014/main" id="{F8BE2243-EF97-76C5-C2DF-23DE74711024}"/>
+              </a:ext>
+            </a:extLst>
+          </p:cNvPr>
+          <p:cNvCxnSpPr>
+            <a:stCxn id="21" idx="2"/>
+          </p:cNvCxnSpPr>
+          <p:nvPr/>
+        </p:nvCxnSpPr>
+        <p:spPr>
+          <a:xfrm>
+            <a:off x="831244" y="1211703"/>
+            <a:ext cx="0" cy="3546151"/>
+          </a:xfrm>
+          <a:prstGeom prst="line">
+            <a:avLst/>
+          </a:prstGeom>
+          <a:ln w="19050">
+            <a:solidFill>
+              <a:schemeClr val="bg2">
+                <a:lumMod val="50000"/>
+              </a:schemeClr>
+            </a:solidFill>
+            <a:prstDash val="sysDash"/>
+          </a:ln>
+        </p:spPr>
+        <p:style>
+          <a:lnRef idx="1">
+            <a:schemeClr val="accent1"/>
+          </a:lnRef>
+          <a:fillRef idx="0">
+            <a:schemeClr val="accent1"/>
+          </a:fillRef>
+          <a:effectRef idx="0">
+            <a:schemeClr val="accent1"/>
+          </a:effectRef>
+          <a:fontRef idx="minor">
+            <a:schemeClr val="tx1"/>
+          </a:fontRef>
+        </p:style>
+      </p:cxnSp>
+      <p:cxnSp>
+        <p:nvCxnSpPr>
+          <p:cNvPr id="11" name="直接连接符 10">
+            <a:extLst>
+              <a:ext uri="{FF2B5EF4-FFF2-40B4-BE49-F238E27FC236}">
+                <a16:creationId xmlns:a16="http://schemas.microsoft.com/office/drawing/2014/main" id="{8DDD8F87-D6F2-A52A-0AC5-D8D38E7E27DB}"/>
+              </a:ext>
+            </a:extLst>
+          </p:cNvPr>
+          <p:cNvCxnSpPr/>
+          <p:nvPr/>
+        </p:nvCxnSpPr>
+        <p:spPr>
+          <a:xfrm>
+            <a:off x="2162402" y="1205928"/>
+            <a:ext cx="0" cy="3546151"/>
+          </a:xfrm>
+          <a:prstGeom prst="line">
+            <a:avLst/>
+          </a:prstGeom>
+          <a:ln w="19050">
+            <a:solidFill>
+              <a:schemeClr val="bg2">
+                <a:lumMod val="50000"/>
+              </a:schemeClr>
+            </a:solidFill>
+            <a:prstDash val="sysDash"/>
+          </a:ln>
+        </p:spPr>
+        <p:style>
+          <a:lnRef idx="1">
+            <a:schemeClr val="accent1"/>
+          </a:lnRef>
+          <a:fillRef idx="0">
+            <a:schemeClr val="accent1"/>
+          </a:fillRef>
+          <a:effectRef idx="0">
+            <a:schemeClr val="accent1"/>
+          </a:effectRef>
+          <a:fontRef idx="minor">
+            <a:schemeClr val="tx1"/>
+          </a:fontRef>
+        </p:style>
+      </p:cxnSp>
+      <p:cxnSp>
+        <p:nvCxnSpPr>
+          <p:cNvPr id="12" name="直接连接符 11">
+            <a:extLst>
+              <a:ext uri="{FF2B5EF4-FFF2-40B4-BE49-F238E27FC236}">
+                <a16:creationId xmlns:a16="http://schemas.microsoft.com/office/drawing/2014/main" id="{17642527-74E3-5D73-7510-3028C3647BA9}"/>
+              </a:ext>
+            </a:extLst>
+          </p:cNvPr>
+          <p:cNvCxnSpPr/>
+          <p:nvPr/>
+        </p:nvCxnSpPr>
+        <p:spPr>
+          <a:xfrm>
+            <a:off x="3988965" y="1205927"/>
+            <a:ext cx="0" cy="3546151"/>
+          </a:xfrm>
+          <a:prstGeom prst="line">
+            <a:avLst/>
+          </a:prstGeom>
+          <a:ln w="19050">
+            <a:solidFill>
+              <a:schemeClr val="bg2">
+                <a:lumMod val="50000"/>
+              </a:schemeClr>
+            </a:solidFill>
+            <a:prstDash val="sysDash"/>
+          </a:ln>
+        </p:spPr>
+        <p:style>
+          <a:lnRef idx="1">
+            <a:schemeClr val="accent1"/>
+          </a:lnRef>
+          <a:fillRef idx="0">
+            <a:schemeClr val="accent1"/>
+          </a:fillRef>
+          <a:effectRef idx="0">
+            <a:schemeClr val="accent1"/>
+          </a:effectRef>
+          <a:fontRef idx="minor">
+            <a:schemeClr val="tx1"/>
+          </a:fontRef>
+        </p:style>
+      </p:cxnSp>
+      <p:cxnSp>
+        <p:nvCxnSpPr>
+          <p:cNvPr id="14" name="直接连接符 13">
+            <a:extLst>
+              <a:ext uri="{FF2B5EF4-FFF2-40B4-BE49-F238E27FC236}">
+                <a16:creationId xmlns:a16="http://schemas.microsoft.com/office/drawing/2014/main" id="{81601A2C-FC3C-7EEE-CC18-3A73C5E8E74F}"/>
+              </a:ext>
+            </a:extLst>
+          </p:cNvPr>
+          <p:cNvCxnSpPr>
+            <a:cxnSpLocks/>
+            <a:stCxn id="20" idx="2"/>
+          </p:cNvCxnSpPr>
+          <p:nvPr/>
+        </p:nvCxnSpPr>
+        <p:spPr>
+          <a:xfrm>
+            <a:off x="6018170" y="1211706"/>
+            <a:ext cx="0" cy="3540372"/>
+          </a:xfrm>
+          <a:prstGeom prst="line">
+            <a:avLst/>
+          </a:prstGeom>
+          <a:ln w="19050">
+            <a:solidFill>
+              <a:schemeClr val="bg2">
+                <a:lumMod val="50000"/>
+              </a:schemeClr>
+            </a:solidFill>
+            <a:prstDash val="sysDash"/>
+          </a:ln>
+        </p:spPr>
+        <p:style>
+          <a:lnRef idx="1">
+            <a:schemeClr val="accent1"/>
+          </a:lnRef>
+          <a:fillRef idx="0">
+            <a:schemeClr val="accent1"/>
+          </a:fillRef>
+          <a:effectRef idx="0">
+            <a:schemeClr val="accent1"/>
+          </a:effectRef>
+          <a:fontRef idx="minor">
+            <a:schemeClr val="tx1"/>
+          </a:fontRef>
+        </p:style>
+      </p:cxnSp>
+      <p:cxnSp>
+        <p:nvCxnSpPr>
+          <p:cNvPr id="17" name="直接连接符 16">
+            <a:extLst>
+              <a:ext uri="{FF2B5EF4-FFF2-40B4-BE49-F238E27FC236}">
+                <a16:creationId xmlns:a16="http://schemas.microsoft.com/office/drawing/2014/main" id="{259A2F24-CD25-558D-14E6-E441485961C2}"/>
+              </a:ext>
+            </a:extLst>
+          </p:cNvPr>
+          <p:cNvCxnSpPr/>
+          <p:nvPr/>
+        </p:nvCxnSpPr>
+        <p:spPr>
+          <a:xfrm>
+            <a:off x="8057144" y="1205927"/>
+            <a:ext cx="0" cy="3546151"/>
+          </a:xfrm>
+          <a:prstGeom prst="line">
+            <a:avLst/>
+          </a:prstGeom>
+          <a:ln w="19050">
+            <a:solidFill>
+              <a:schemeClr val="bg2">
+                <a:lumMod val="50000"/>
+              </a:schemeClr>
+            </a:solidFill>
+            <a:prstDash val="sysDash"/>
+          </a:ln>
+        </p:spPr>
+        <p:style>
+          <a:lnRef idx="1">
+            <a:schemeClr val="accent1"/>
+          </a:lnRef>
+          <a:fillRef idx="0">
+            <a:schemeClr val="accent1"/>
+          </a:fillRef>
+          <a:effectRef idx="0">
+            <a:schemeClr val="accent1"/>
+          </a:effectRef>
+          <a:fontRef idx="minor">
+            <a:schemeClr val="tx1"/>
+          </a:fontRef>
+        </p:style>
+      </p:cxnSp>
+      <p:cxnSp>
+        <p:nvCxnSpPr>
+          <p:cNvPr id="19" name="直接箭头连接符 18">
+            <a:extLst>
+              <a:ext uri="{FF2B5EF4-FFF2-40B4-BE49-F238E27FC236}">
+                <a16:creationId xmlns:a16="http://schemas.microsoft.com/office/drawing/2014/main" id="{EA1A64BF-0603-205D-5EB0-B8CE50235296}"/>
+              </a:ext>
+            </a:extLst>
+          </p:cNvPr>
+          <p:cNvCxnSpPr/>
+          <p:nvPr/>
+        </p:nvCxnSpPr>
+        <p:spPr>
+          <a:xfrm>
+            <a:off x="824848" y="1465688"/>
+            <a:ext cx="1331158" cy="0"/>
+          </a:xfrm>
+          <a:prstGeom prst="straightConnector1">
+            <a:avLst/>
+          </a:prstGeom>
+          <a:ln w="38100">
+            <a:tailEnd type="triangle"/>
+          </a:ln>
+        </p:spPr>
+        <p:style>
+          <a:lnRef idx="1">
+            <a:schemeClr val="accent1"/>
+          </a:lnRef>
+          <a:fillRef idx="0">
+            <a:schemeClr val="accent1"/>
+          </a:fillRef>
+          <a:effectRef idx="0">
+            <a:schemeClr val="accent1"/>
+          </a:effectRef>
+          <a:fontRef idx="minor">
+            <a:schemeClr val="tx1"/>
+          </a:fontRef>
+        </p:style>
+      </p:cxnSp>
+      <p:sp>
+        <p:nvSpPr>
+          <p:cNvPr id="24" name="文本框 23">
+            <a:extLst>
+              <a:ext uri="{FF2B5EF4-FFF2-40B4-BE49-F238E27FC236}">
+                <a16:creationId xmlns:a16="http://schemas.microsoft.com/office/drawing/2014/main" id="{506F288E-709B-AA42-E0A0-4A4594F04BDC}"/>
+              </a:ext>
+            </a:extLst>
+          </p:cNvPr>
+          <p:cNvSpPr txBox="1"/>
+          <p:nvPr/>
+        </p:nvSpPr>
+        <p:spPr>
+          <a:xfrm>
+            <a:off x="1060178" y="1217479"/>
+            <a:ext cx="734496" cy="248209"/>
+          </a:xfrm>
+          <a:prstGeom prst="rect">
+            <a:avLst/>
+          </a:prstGeom>
+          <a:noFill/>
+        </p:spPr>
+        <p:txBody>
+          <a:bodyPr wrap="none" rtlCol="0">
+            <a:spAutoFit/>
+          </a:bodyPr>
+          <a:lstStyle/>
+          <a:p>
+            <a:r>
+              <a:rPr lang="en-US" altLang="zh-CN" sz="1013" b="1" dirty="0"/>
+              <a:t>Topic</a:t>
+            </a:r>
+            <a:r>
+              <a:rPr lang="zh-CN" altLang="en-US" sz="1013" b="1" dirty="0"/>
+              <a:t>枚举</a:t>
+            </a:r>
+            <a:endParaRPr lang="en-US" altLang="zh-CN" sz="1013" b="1" dirty="0"/>
+          </a:p>
+        </p:txBody>
+      </p:sp>
+      <p:sp>
+        <p:nvSpPr>
+          <p:cNvPr id="25" name="文本框 24">
+            <a:extLst>
+              <a:ext uri="{FF2B5EF4-FFF2-40B4-BE49-F238E27FC236}">
+                <a16:creationId xmlns:a16="http://schemas.microsoft.com/office/drawing/2014/main" id="{CE2E97F4-09B9-63BB-AD87-78E0B721CA00}"/>
+              </a:ext>
+            </a:extLst>
+          </p:cNvPr>
+          <p:cNvSpPr txBox="1"/>
+          <p:nvPr/>
+        </p:nvSpPr>
+        <p:spPr>
+          <a:xfrm>
+            <a:off x="1035247" y="1596624"/>
+            <a:ext cx="974947" cy="248209"/>
+          </a:xfrm>
+          <a:prstGeom prst="rect">
+            <a:avLst/>
+          </a:prstGeom>
+          <a:noFill/>
+        </p:spPr>
+        <p:txBody>
+          <a:bodyPr wrap="none" rtlCol="0">
+            <a:spAutoFit/>
+          </a:bodyPr>
+          <a:lstStyle/>
+          <a:p>
+            <a:r>
+              <a:rPr lang="zh-CN" altLang="en-US" sz="1013" b="1" dirty="0"/>
+              <a:t>识别目标</a:t>
+            </a:r>
+            <a:r>
+              <a:rPr lang="en-US" altLang="zh-CN" sz="1013" b="1" dirty="0"/>
+              <a:t>topic</a:t>
+            </a:r>
+          </a:p>
+        </p:txBody>
+      </p:sp>
+      <p:cxnSp>
+        <p:nvCxnSpPr>
+          <p:cNvPr id="26" name="直接箭头连接符 25">
+            <a:extLst>
+              <a:ext uri="{FF2B5EF4-FFF2-40B4-BE49-F238E27FC236}">
+                <a16:creationId xmlns:a16="http://schemas.microsoft.com/office/drawing/2014/main" id="{3B214CAA-D45C-6588-DDCD-6C930D2FB432}"/>
+              </a:ext>
+            </a:extLst>
+          </p:cNvPr>
+          <p:cNvCxnSpPr>
+            <a:cxnSpLocks/>
+          </p:cNvCxnSpPr>
+          <p:nvPr/>
+        </p:nvCxnSpPr>
+        <p:spPr>
+          <a:xfrm flipH="1">
+            <a:off x="771874" y="1839649"/>
+            <a:ext cx="1384132" cy="0"/>
+          </a:xfrm>
+          <a:prstGeom prst="straightConnector1">
+            <a:avLst/>
+          </a:prstGeom>
+          <a:ln w="38100">
+            <a:tailEnd type="triangle"/>
+          </a:ln>
+        </p:spPr>
+        <p:style>
+          <a:lnRef idx="1">
+            <a:schemeClr val="accent1"/>
+          </a:lnRef>
+          <a:fillRef idx="0">
+            <a:schemeClr val="accent1"/>
+          </a:fillRef>
+          <a:effectRef idx="0">
+            <a:schemeClr val="accent1"/>
+          </a:effectRef>
+          <a:fontRef idx="minor">
+            <a:schemeClr val="tx1"/>
+          </a:fontRef>
+        </p:style>
+      </p:cxnSp>
+      <p:cxnSp>
+        <p:nvCxnSpPr>
+          <p:cNvPr id="30" name="直接箭头连接符 29">
+            <a:extLst>
+              <a:ext uri="{FF2B5EF4-FFF2-40B4-BE49-F238E27FC236}">
+                <a16:creationId xmlns:a16="http://schemas.microsoft.com/office/drawing/2014/main" id="{7C61E4C0-2EE6-4126-D851-D11A16273951}"/>
+              </a:ext>
+            </a:extLst>
+          </p:cNvPr>
+          <p:cNvCxnSpPr/>
+          <p:nvPr/>
+        </p:nvCxnSpPr>
+        <p:spPr>
+          <a:xfrm>
+            <a:off x="836971" y="2336067"/>
+            <a:ext cx="1331158" cy="0"/>
+          </a:xfrm>
+          <a:prstGeom prst="straightConnector1">
+            <a:avLst/>
+          </a:prstGeom>
+          <a:ln w="38100">
+            <a:tailEnd type="triangle"/>
+          </a:ln>
+        </p:spPr>
+        <p:style>
+          <a:lnRef idx="1">
+            <a:schemeClr val="accent1"/>
+          </a:lnRef>
+          <a:fillRef idx="0">
+            <a:schemeClr val="accent1"/>
+          </a:fillRef>
+          <a:effectRef idx="0">
+            <a:schemeClr val="accent1"/>
+          </a:effectRef>
+          <a:fontRef idx="minor">
+            <a:schemeClr val="tx1"/>
+          </a:fontRef>
+        </p:style>
+      </p:cxnSp>
+      <p:sp>
+        <p:nvSpPr>
+          <p:cNvPr id="31" name="文本框 30">
+            <a:extLst>
+              <a:ext uri="{FF2B5EF4-FFF2-40B4-BE49-F238E27FC236}">
+                <a16:creationId xmlns:a16="http://schemas.microsoft.com/office/drawing/2014/main" id="{B9A5B225-9D49-3560-FF62-613C976BAFFB}"/>
+              </a:ext>
+            </a:extLst>
+          </p:cNvPr>
+          <p:cNvSpPr txBox="1"/>
+          <p:nvPr/>
+        </p:nvSpPr>
+        <p:spPr>
+          <a:xfrm>
+            <a:off x="1072301" y="2087858"/>
+            <a:ext cx="704039" cy="248209"/>
+          </a:xfrm>
+          <a:prstGeom prst="rect">
+            <a:avLst/>
+          </a:prstGeom>
+          <a:noFill/>
+        </p:spPr>
+        <p:txBody>
+          <a:bodyPr wrap="none" rtlCol="0">
+            <a:spAutoFit/>
+          </a:bodyPr>
+          <a:lstStyle/>
+          <a:p>
+            <a:r>
+              <a:rPr lang="zh-CN" altLang="en-US" sz="1013" b="1" dirty="0"/>
+              <a:t>查询类型</a:t>
+            </a:r>
+            <a:endParaRPr lang="en-US" altLang="zh-CN" sz="1013" b="1" dirty="0"/>
+          </a:p>
+        </p:txBody>
+      </p:sp>
+      <p:sp>
+        <p:nvSpPr>
+          <p:cNvPr id="32" name="文本框 31">
+            <a:extLst>
+              <a:ext uri="{FF2B5EF4-FFF2-40B4-BE49-F238E27FC236}">
+                <a16:creationId xmlns:a16="http://schemas.microsoft.com/office/drawing/2014/main" id="{7DE38ADF-58BB-5D92-28AB-CEF2DE63801F}"/>
+              </a:ext>
+            </a:extLst>
+          </p:cNvPr>
+          <p:cNvSpPr txBox="1"/>
+          <p:nvPr/>
+        </p:nvSpPr>
+        <p:spPr>
+          <a:xfrm>
+            <a:off x="1133108" y="2461819"/>
+            <a:ext cx="724878" cy="248209"/>
+          </a:xfrm>
+          <a:prstGeom prst="rect">
+            <a:avLst/>
+          </a:prstGeom>
+          <a:noFill/>
+        </p:spPr>
+        <p:txBody>
+          <a:bodyPr wrap="none" rtlCol="0">
+            <a:spAutoFit/>
+          </a:bodyPr>
+          <a:lstStyle/>
+          <a:p>
+            <a:r>
+              <a:rPr lang="en-US" altLang="zh-CN" sz="1013" b="1" dirty="0" err="1"/>
+              <a:t>JointState</a:t>
+            </a:r>
+            <a:endParaRPr lang="en-US" altLang="zh-CN" sz="1013" b="1" dirty="0"/>
+          </a:p>
+        </p:txBody>
+      </p:sp>
+      <p:cxnSp>
+        <p:nvCxnSpPr>
+          <p:cNvPr id="33" name="直接箭头连接符 32">
+            <a:extLst>
+              <a:ext uri="{FF2B5EF4-FFF2-40B4-BE49-F238E27FC236}">
+                <a16:creationId xmlns:a16="http://schemas.microsoft.com/office/drawing/2014/main" id="{3FDEA29A-58F2-1159-3E8F-364845988628}"/>
+              </a:ext>
+            </a:extLst>
+          </p:cNvPr>
+          <p:cNvCxnSpPr>
+            <a:cxnSpLocks/>
+          </p:cNvCxnSpPr>
+          <p:nvPr/>
+        </p:nvCxnSpPr>
+        <p:spPr>
+          <a:xfrm flipH="1">
+            <a:off x="783997" y="2710028"/>
+            <a:ext cx="1384132" cy="0"/>
+          </a:xfrm>
+          <a:prstGeom prst="straightConnector1">
+            <a:avLst/>
+          </a:prstGeom>
+          <a:ln w="38100">
+            <a:tailEnd type="triangle"/>
+          </a:ln>
+        </p:spPr>
+        <p:style>
+          <a:lnRef idx="1">
+            <a:schemeClr val="accent1"/>
+          </a:lnRef>
+          <a:fillRef idx="0">
+            <a:schemeClr val="accent1"/>
+          </a:fillRef>
+          <a:effectRef idx="0">
+            <a:schemeClr val="accent1"/>
+          </a:effectRef>
+          <a:fontRef idx="minor">
+            <a:schemeClr val="tx1"/>
+          </a:fontRef>
+        </p:style>
+      </p:cxnSp>
+      <p:sp>
+        <p:nvSpPr>
+          <p:cNvPr id="35" name="文本框 34">
+            <a:extLst>
+              <a:ext uri="{FF2B5EF4-FFF2-40B4-BE49-F238E27FC236}">
+                <a16:creationId xmlns:a16="http://schemas.microsoft.com/office/drawing/2014/main" id="{38B5688E-6F9D-1486-1E57-7DBF589846D1}"/>
+              </a:ext>
+            </a:extLst>
+          </p:cNvPr>
+          <p:cNvSpPr txBox="1"/>
+          <p:nvPr/>
+        </p:nvSpPr>
+        <p:spPr>
+          <a:xfrm>
+            <a:off x="998222" y="2835779"/>
+            <a:ext cx="1061837" cy="248209"/>
+          </a:xfrm>
+          <a:prstGeom prst="rect">
+            <a:avLst/>
+          </a:prstGeom>
+          <a:noFill/>
+        </p:spPr>
+        <p:txBody>
+          <a:bodyPr wrap="square" rtlCol="0">
+            <a:spAutoFit/>
+          </a:bodyPr>
+          <a:lstStyle/>
+          <a:p>
+            <a:r>
+              <a:rPr lang="zh-CN" altLang="en-US" sz="1013" b="1" dirty="0"/>
+              <a:t>构造合法消息</a:t>
+            </a:r>
+            <a:endParaRPr lang="en-US" altLang="zh-CN" sz="1013" b="1" dirty="0"/>
+          </a:p>
+        </p:txBody>
+      </p:sp>
+      <p:cxnSp>
+        <p:nvCxnSpPr>
+          <p:cNvPr id="37" name="直接箭头连接符 36">
+            <a:extLst>
+              <a:ext uri="{FF2B5EF4-FFF2-40B4-BE49-F238E27FC236}">
+                <a16:creationId xmlns:a16="http://schemas.microsoft.com/office/drawing/2014/main" id="{E2192826-111C-8738-013E-336D1FBF88FC}"/>
+              </a:ext>
+            </a:extLst>
+          </p:cNvPr>
+          <p:cNvCxnSpPr>
+            <a:cxnSpLocks/>
+          </p:cNvCxnSpPr>
+          <p:nvPr/>
+        </p:nvCxnSpPr>
+        <p:spPr>
+          <a:xfrm>
+            <a:off x="834616" y="3456301"/>
+            <a:ext cx="3141553" cy="0"/>
+          </a:xfrm>
+          <a:prstGeom prst="straightConnector1">
+            <a:avLst/>
+          </a:prstGeom>
+          <a:ln w="38100">
+            <a:tailEnd type="triangle"/>
+          </a:ln>
+        </p:spPr>
+        <p:style>
+          <a:lnRef idx="1">
+            <a:schemeClr val="accent1"/>
+          </a:lnRef>
+          <a:fillRef idx="0">
+            <a:schemeClr val="accent1"/>
+          </a:fillRef>
+          <a:effectRef idx="0">
+            <a:schemeClr val="accent1"/>
+          </a:effectRef>
+          <a:fontRef idx="minor">
+            <a:schemeClr val="tx1"/>
+          </a:fontRef>
+        </p:style>
+      </p:cxnSp>
+      <p:sp>
+        <p:nvSpPr>
+          <p:cNvPr id="39" name="文本框 38">
+            <a:extLst>
+              <a:ext uri="{FF2B5EF4-FFF2-40B4-BE49-F238E27FC236}">
+                <a16:creationId xmlns:a16="http://schemas.microsoft.com/office/drawing/2014/main" id="{06F6D5FB-4E6E-C435-23B9-BD3458ACFE24}"/>
+              </a:ext>
+            </a:extLst>
+          </p:cNvPr>
+          <p:cNvSpPr txBox="1"/>
+          <p:nvPr/>
+        </p:nvSpPr>
+        <p:spPr>
+          <a:xfrm>
+            <a:off x="831244" y="3208092"/>
+            <a:ext cx="1599651" cy="248209"/>
+          </a:xfrm>
+          <a:prstGeom prst="rect">
+            <a:avLst/>
+          </a:prstGeom>
+          <a:noFill/>
+        </p:spPr>
+        <p:txBody>
+          <a:bodyPr wrap="square" rtlCol="0">
+            <a:spAutoFit/>
+          </a:bodyPr>
+          <a:lstStyle/>
+          <a:p>
+            <a:r>
+              <a:rPr lang="zh-CN" altLang="en-US" sz="1013" b="1" dirty="0"/>
+              <a:t>发布 </a:t>
+            </a:r>
+            <a:r>
+              <a:rPr lang="en-US" altLang="zh-CN" sz="1013" b="1" dirty="0"/>
+              <a:t>forged </a:t>
+            </a:r>
+            <a:r>
+              <a:rPr lang="en-US" altLang="zh-CN" sz="1013" b="1" dirty="0" err="1"/>
+              <a:t>JointState</a:t>
+            </a:r>
+            <a:endParaRPr lang="en-US" altLang="zh-CN" sz="1013" b="1" dirty="0"/>
+          </a:p>
+        </p:txBody>
+      </p:sp>
+      <p:cxnSp>
+        <p:nvCxnSpPr>
+          <p:cNvPr id="40" name="直接箭头连接符 39">
+            <a:extLst>
+              <a:ext uri="{FF2B5EF4-FFF2-40B4-BE49-F238E27FC236}">
+                <a16:creationId xmlns:a16="http://schemas.microsoft.com/office/drawing/2014/main" id="{4D1506E5-8147-F5A1-52AA-7639FA875480}"/>
+              </a:ext>
+            </a:extLst>
+          </p:cNvPr>
+          <p:cNvCxnSpPr>
+            <a:cxnSpLocks/>
+          </p:cNvCxnSpPr>
+          <p:nvPr/>
+        </p:nvCxnSpPr>
+        <p:spPr>
+          <a:xfrm>
+            <a:off x="4001055" y="3964307"/>
+            <a:ext cx="2020488" cy="0"/>
+          </a:xfrm>
+          <a:prstGeom prst="straightConnector1">
+            <a:avLst/>
+          </a:prstGeom>
+          <a:ln w="38100">
+            <a:tailEnd type="triangle"/>
+          </a:ln>
+        </p:spPr>
+        <p:style>
+          <a:lnRef idx="1">
+            <a:schemeClr val="accent1"/>
+          </a:lnRef>
+          <a:fillRef idx="0">
+            <a:schemeClr val="accent1"/>
+          </a:fillRef>
+          <a:effectRef idx="0">
+            <a:schemeClr val="accent1"/>
+          </a:effectRef>
+          <a:fontRef idx="minor">
+            <a:schemeClr val="tx1"/>
+          </a:fontRef>
+        </p:style>
+      </p:cxnSp>
+      <p:sp>
+        <p:nvSpPr>
+          <p:cNvPr id="41" name="文本框 40">
+            <a:extLst>
+              <a:ext uri="{FF2B5EF4-FFF2-40B4-BE49-F238E27FC236}">
+                <a16:creationId xmlns:a16="http://schemas.microsoft.com/office/drawing/2014/main" id="{C1983F8C-F687-EEB2-4E1C-1A41308EB52A}"/>
+              </a:ext>
+            </a:extLst>
+          </p:cNvPr>
+          <p:cNvSpPr txBox="1"/>
+          <p:nvPr/>
+        </p:nvSpPr>
+        <p:spPr>
+          <a:xfrm>
+            <a:off x="4510354" y="3721501"/>
+            <a:ext cx="1211414" cy="248209"/>
+          </a:xfrm>
+          <a:prstGeom prst="rect">
+            <a:avLst/>
+          </a:prstGeom>
+          <a:noFill/>
+        </p:spPr>
+        <p:txBody>
+          <a:bodyPr wrap="square" rtlCol="0">
+            <a:spAutoFit/>
+          </a:bodyPr>
+          <a:lstStyle/>
+          <a:p>
+            <a:r>
+              <a:rPr lang="zh-CN" altLang="en-US" sz="1013" b="1" dirty="0"/>
+              <a:t>被订阅</a:t>
+            </a:r>
+            <a:r>
+              <a:rPr lang="en-US" altLang="zh-CN" sz="1013" b="1" dirty="0"/>
+              <a:t>/</a:t>
+            </a:r>
+            <a:r>
+              <a:rPr lang="zh-CN" altLang="en-US" sz="1013" b="1" dirty="0"/>
+              <a:t>处理</a:t>
+            </a:r>
+            <a:endParaRPr lang="en-US" altLang="zh-CN" sz="1013" b="1" dirty="0"/>
+          </a:p>
+        </p:txBody>
+      </p:sp>
+      <p:cxnSp>
+        <p:nvCxnSpPr>
+          <p:cNvPr id="43" name="直接箭头连接符 42">
+            <a:extLst>
+              <a:ext uri="{FF2B5EF4-FFF2-40B4-BE49-F238E27FC236}">
+                <a16:creationId xmlns:a16="http://schemas.microsoft.com/office/drawing/2014/main" id="{82E6E458-E41E-B9A9-0B0E-340AD8FD418F}"/>
+              </a:ext>
+            </a:extLst>
+          </p:cNvPr>
+          <p:cNvCxnSpPr>
+            <a:cxnSpLocks/>
+          </p:cNvCxnSpPr>
+          <p:nvPr/>
+        </p:nvCxnSpPr>
+        <p:spPr>
+          <a:xfrm>
+            <a:off x="6052932" y="4174600"/>
+            <a:ext cx="2020488" cy="0"/>
+          </a:xfrm>
+          <a:prstGeom prst="straightConnector1">
+            <a:avLst/>
+          </a:prstGeom>
+          <a:ln w="38100">
+            <a:tailEnd type="triangle"/>
+          </a:ln>
+        </p:spPr>
+        <p:style>
+          <a:lnRef idx="1">
+            <a:schemeClr val="accent1"/>
+          </a:lnRef>
+          <a:fillRef idx="0">
+            <a:schemeClr val="accent1"/>
+          </a:fillRef>
+          <a:effectRef idx="0">
+            <a:schemeClr val="accent1"/>
+          </a:effectRef>
+          <a:fontRef idx="minor">
+            <a:schemeClr val="tx1"/>
+          </a:fontRef>
+        </p:style>
+      </p:cxnSp>
+      <p:sp>
+        <p:nvSpPr>
+          <p:cNvPr id="57" name="文本框 56">
+            <a:extLst>
+              <a:ext uri="{FF2B5EF4-FFF2-40B4-BE49-F238E27FC236}">
+                <a16:creationId xmlns:a16="http://schemas.microsoft.com/office/drawing/2014/main" id="{BDF3CB6F-3833-EA1F-097D-2FEAD5C0683B}"/>
+              </a:ext>
+            </a:extLst>
+          </p:cNvPr>
+          <p:cNvSpPr txBox="1"/>
+          <p:nvPr/>
+        </p:nvSpPr>
+        <p:spPr>
+          <a:xfrm>
+            <a:off x="6562231" y="3931794"/>
+            <a:ext cx="1211414" cy="248209"/>
+          </a:xfrm>
+          <a:prstGeom prst="rect">
+            <a:avLst/>
+          </a:prstGeom>
+          <a:noFill/>
+        </p:spPr>
+        <p:txBody>
+          <a:bodyPr wrap="square" rtlCol="0">
+            <a:spAutoFit/>
+          </a:bodyPr>
+          <a:lstStyle/>
+          <a:p>
+            <a:r>
+              <a:rPr lang="zh-CN" altLang="en-US" sz="1013" b="1" dirty="0"/>
+              <a:t>更新 </a:t>
+            </a:r>
+            <a:r>
+              <a:rPr lang="en-US" altLang="zh-CN" sz="1013" b="1" dirty="0"/>
+              <a:t>TF/</a:t>
+            </a:r>
+            <a:r>
+              <a:rPr lang="zh-CN" altLang="en-US" sz="1013" b="1" dirty="0"/>
+              <a:t>误导</a:t>
+            </a:r>
+            <a:r>
+              <a:rPr lang="en-US" altLang="zh-CN" sz="1013" b="1" dirty="0"/>
+              <a:t>RViz</a:t>
+            </a:r>
+          </a:p>
+        </p:txBody>
+      </p:sp>
+      <p:cxnSp>
+        <p:nvCxnSpPr>
+          <p:cNvPr id="58" name="直接箭头连接符 57">
+            <a:extLst>
+              <a:ext uri="{FF2B5EF4-FFF2-40B4-BE49-F238E27FC236}">
+                <a16:creationId xmlns:a16="http://schemas.microsoft.com/office/drawing/2014/main" id="{7333B166-3820-B459-DA8D-C2356DF1326A}"/>
+              </a:ext>
+            </a:extLst>
+          </p:cNvPr>
+          <p:cNvCxnSpPr>
+            <a:cxnSpLocks/>
+          </p:cNvCxnSpPr>
+          <p:nvPr/>
+        </p:nvCxnSpPr>
+        <p:spPr>
+          <a:xfrm>
+            <a:off x="860700" y="4617969"/>
+            <a:ext cx="7193072" cy="5681"/>
+          </a:xfrm>
+          <a:prstGeom prst="straightConnector1">
+            <a:avLst/>
+          </a:prstGeom>
+          <a:ln w="38100">
+            <a:tailEnd type="triangle"/>
+          </a:ln>
+        </p:spPr>
+        <p:style>
+          <a:lnRef idx="1">
+            <a:schemeClr val="accent1"/>
+          </a:lnRef>
+          <a:fillRef idx="0">
+            <a:schemeClr val="accent1"/>
+          </a:fillRef>
+          <a:effectRef idx="0">
+            <a:schemeClr val="accent1"/>
+          </a:effectRef>
+          <a:fontRef idx="minor">
+            <a:schemeClr val="tx1"/>
+          </a:fontRef>
+        </p:style>
+      </p:cxnSp>
+      <p:sp>
+        <p:nvSpPr>
+          <p:cNvPr id="59" name="文本框 58">
+            <a:extLst>
+              <a:ext uri="{FF2B5EF4-FFF2-40B4-BE49-F238E27FC236}">
+                <a16:creationId xmlns:a16="http://schemas.microsoft.com/office/drawing/2014/main" id="{FFEC95B3-096C-DC08-CB43-C6DAED5E07D5}"/>
+              </a:ext>
+            </a:extLst>
+          </p:cNvPr>
+          <p:cNvSpPr txBox="1"/>
+          <p:nvPr/>
+        </p:nvSpPr>
+        <p:spPr>
+          <a:xfrm>
+            <a:off x="6505053" y="4364358"/>
+            <a:ext cx="1061837" cy="248209"/>
+          </a:xfrm>
+          <a:prstGeom prst="rect">
+            <a:avLst/>
+          </a:prstGeom>
+          <a:noFill/>
+        </p:spPr>
+        <p:txBody>
+          <a:bodyPr wrap="square" rtlCol="0">
+            <a:spAutoFit/>
+          </a:bodyPr>
+          <a:lstStyle/>
+          <a:p>
+            <a:r>
+              <a:rPr lang="zh-CN" altLang="en-US" sz="1013" b="1" dirty="0"/>
+              <a:t>误导显示</a:t>
+            </a:r>
+            <a:endParaRPr lang="en-US" altLang="zh-CN" sz="1013" b="1" dirty="0"/>
+          </a:p>
+        </p:txBody>
+      </p:sp>
+      <p:sp>
+        <p:nvSpPr>
+          <p:cNvPr id="64" name="标注: 下箭头 63">
+            <a:extLst>
+              <a:ext uri="{FF2B5EF4-FFF2-40B4-BE49-F238E27FC236}">
+                <a16:creationId xmlns:a16="http://schemas.microsoft.com/office/drawing/2014/main" id="{D077E3E9-7F43-B2A5-1AFA-68FF1265EF19}"/>
+              </a:ext>
+            </a:extLst>
+          </p:cNvPr>
+          <p:cNvSpPr/>
+          <p:nvPr/>
+        </p:nvSpPr>
+        <p:spPr>
+          <a:xfrm>
+            <a:off x="2383010" y="2467003"/>
+            <a:ext cx="1315128" cy="985759"/>
+          </a:xfrm>
+          <a:prstGeom prst="downArrowCallout">
+            <a:avLst/>
+          </a:prstGeom>
+          <a:solidFill>
+            <a:schemeClr val="bg1"/>
+          </a:solidFill>
+          <a:ln>
+            <a:solidFill>
+              <a:schemeClr val="tx1"/>
+            </a:solidFill>
+          </a:ln>
+        </p:spPr>
+        <p:style>
+          <a:lnRef idx="2">
+            <a:schemeClr val="accent1">
+              <a:shade val="15000"/>
+            </a:schemeClr>
+          </a:lnRef>
+          <a:fillRef idx="1">
+            <a:schemeClr val="accent1"/>
+          </a:fillRef>
+          <a:effectRef idx="0">
+            <a:schemeClr val="accent1"/>
+          </a:effectRef>
+          <a:fontRef idx="minor">
+            <a:schemeClr val="lt1"/>
+          </a:fontRef>
+        </p:style>
+        <p:txBody>
+          <a:bodyPr rtlCol="0" anchor="ctr"/>
+          <a:lstStyle/>
+          <a:p>
+            <a:pPr algn="ctr"/>
+            <a:r>
+              <a:rPr lang="zh-CN" altLang="en-US" sz="1000" b="1" dirty="0">
+                <a:solidFill>
+                  <a:schemeClr val="tx1"/>
+                </a:solidFill>
+              </a:rPr>
+              <a:t>关键条件：</a:t>
+            </a:r>
+          </a:p>
+          <a:p>
+            <a:pPr algn="ctr"/>
+            <a:r>
+              <a:rPr lang="en-US" altLang="zh-CN" sz="1000" b="1" dirty="0">
+                <a:solidFill>
+                  <a:schemeClr val="tx1"/>
+                </a:solidFill>
+              </a:rPr>
+              <a:t>- </a:t>
+            </a:r>
+            <a:r>
+              <a:rPr lang="zh-CN" altLang="en-US" sz="1000" b="1" dirty="0">
+                <a:solidFill>
+                  <a:schemeClr val="tx1"/>
+                </a:solidFill>
+              </a:rPr>
+              <a:t>关节名称匹配</a:t>
+            </a:r>
+          </a:p>
+          <a:p>
+            <a:pPr algn="ctr"/>
+            <a:r>
+              <a:rPr lang="en-US" altLang="zh-CN" sz="1000" b="1" dirty="0">
+                <a:solidFill>
+                  <a:schemeClr val="tx1"/>
+                </a:solidFill>
+              </a:rPr>
+              <a:t>- </a:t>
+            </a:r>
+            <a:r>
+              <a:rPr lang="zh-CN" altLang="en-US" sz="1000" b="1" dirty="0">
+                <a:solidFill>
+                  <a:schemeClr val="tx1"/>
+                </a:solidFill>
+              </a:rPr>
+              <a:t>关节范围合法</a:t>
+            </a:r>
+          </a:p>
+          <a:p>
+            <a:pPr algn="ctr"/>
+            <a:r>
+              <a:rPr lang="en-US" altLang="zh-CN" sz="1000" b="1" dirty="0">
+                <a:solidFill>
+                  <a:schemeClr val="tx1"/>
+                </a:solidFill>
+              </a:rPr>
+              <a:t>- </a:t>
+            </a:r>
+            <a:r>
+              <a:rPr lang="zh-CN" altLang="en-US" sz="1000" b="1" dirty="0">
+                <a:solidFill>
+                  <a:schemeClr val="tx1"/>
+                </a:solidFill>
+              </a:rPr>
+              <a:t>时间戳有效</a:t>
+            </a:r>
+          </a:p>
+        </p:txBody>
+      </p:sp>
+    </p:spTree>
+    <p:extLst>
+      <p:ext uri="{BB962C8B-B14F-4D97-AF65-F5344CB8AC3E}">
+        <p14:creationId xmlns:p14="http://schemas.microsoft.com/office/powerpoint/2010/main" val="2315500915"/>
+      </p:ext>
+    </p:extLst>
+  </p:cSld>
+  <p:clrMapOvr>
+    <a:masterClrMapping/>
+  </p:clrMapOvr>
+</p:sld>
+</file>
+
+<file path=ppt/slides/slide5.xml><?xml version="1.0" encoding="utf-8"?>
+<p:sld xmlns:a="http://schemas.openxmlformats.org/drawingml/2006/main" xmlns:r="http://schemas.openxmlformats.org/officeDocument/2006/relationships" xmlns:p="http://schemas.openxmlformats.org/presentationml/2006/main">
+  <p:cSld>
+    <p:spTree>
+      <p:nvGrpSpPr>
+        <p:cNvPr id="1" name="">
+          <a:extLst>
+            <a:ext uri="{FF2B5EF4-FFF2-40B4-BE49-F238E27FC236}">
+              <a16:creationId xmlns:a16="http://schemas.microsoft.com/office/drawing/2014/main" id="{1B4DB2E3-675D-57C3-B803-E943FBE776C9}"/>
+            </a:ext>
+          </a:extLst>
+        </p:cNvPr>
+        <p:cNvGrpSpPr/>
+        <p:nvPr/>
+      </p:nvGrpSpPr>
+      <p:grpSpPr>
+        <a:xfrm>
+          <a:off x="0" y="0"/>
+          <a:ext cx="0" cy="0"/>
+          <a:chOff x="0" y="0"/>
+          <a:chExt cx="0" cy="0"/>
+        </a:xfrm>
+      </p:grpSpPr>
+      <p:sp>
+        <p:nvSpPr>
+          <p:cNvPr id="4" name="流程图: 过程 3">
+            <a:extLst>
+              <a:ext uri="{FF2B5EF4-FFF2-40B4-BE49-F238E27FC236}">
+                <a16:creationId xmlns:a16="http://schemas.microsoft.com/office/drawing/2014/main" id="{2CB30021-B770-F417-E08D-D10C3CA7062D}"/>
+              </a:ext>
+            </a:extLst>
+          </p:cNvPr>
+          <p:cNvSpPr/>
+          <p:nvPr/>
+        </p:nvSpPr>
+        <p:spPr>
+          <a:xfrm>
+            <a:off x="1037637" y="586012"/>
+            <a:ext cx="1120078" cy="248209"/>
+          </a:xfrm>
+          <a:prstGeom prst="flowChartProcess">
+            <a:avLst/>
+          </a:prstGeom>
+          <a:solidFill>
+            <a:schemeClr val="accent1">
+              <a:lumMod val="60000"/>
+              <a:lumOff val="40000"/>
+            </a:schemeClr>
+          </a:solidFill>
+        </p:spPr>
+        <p:style>
+          <a:lnRef idx="2">
+            <a:schemeClr val="accent1">
+              <a:shade val="15000"/>
+            </a:schemeClr>
+          </a:lnRef>
+          <a:fillRef idx="1">
+            <a:schemeClr val="accent1"/>
+          </a:fillRef>
+          <a:effectRef idx="0">
+            <a:schemeClr val="accent1"/>
+          </a:effectRef>
+          <a:fontRef idx="minor">
+            <a:schemeClr val="lt1"/>
+          </a:fontRef>
+        </p:style>
+        <p:txBody>
+          <a:bodyPr rtlCol="0" anchor="ctr"/>
+          <a:lstStyle/>
+          <a:p>
+            <a:pPr algn="ctr"/>
+            <a:r>
+              <a:rPr lang="zh-CN" altLang="en-US" sz="1013" b="1" dirty="0">
+                <a:solidFill>
+                  <a:schemeClr val="tx1"/>
+                </a:solidFill>
+              </a:rPr>
+              <a:t>攻击者节点</a:t>
+            </a:r>
+          </a:p>
+        </p:txBody>
+      </p:sp>
+      <p:sp>
+        <p:nvSpPr>
+          <p:cNvPr id="5" name="流程图: 过程 4">
+            <a:extLst>
+              <a:ext uri="{FF2B5EF4-FFF2-40B4-BE49-F238E27FC236}">
+                <a16:creationId xmlns:a16="http://schemas.microsoft.com/office/drawing/2014/main" id="{34D6B80A-72E0-14EA-A007-119F214B509F}"/>
+              </a:ext>
+            </a:extLst>
+          </p:cNvPr>
+          <p:cNvSpPr/>
+          <p:nvPr/>
+        </p:nvSpPr>
+        <p:spPr>
+          <a:xfrm>
+            <a:off x="3649628" y="157555"/>
+            <a:ext cx="1185612" cy="259761"/>
+          </a:xfrm>
+          <a:prstGeom prst="flowChartProcess">
+            <a:avLst/>
+          </a:prstGeom>
+          <a:solidFill>
+            <a:schemeClr val="accent2">
+              <a:lumMod val="40000"/>
+              <a:lumOff val="60000"/>
+            </a:schemeClr>
+          </a:solidFill>
+        </p:spPr>
+        <p:style>
+          <a:lnRef idx="2">
+            <a:schemeClr val="accent1">
+              <a:shade val="15000"/>
+            </a:schemeClr>
+          </a:lnRef>
+          <a:fillRef idx="1">
+            <a:schemeClr val="accent1"/>
+          </a:fillRef>
+          <a:effectRef idx="0">
+            <a:schemeClr val="accent1"/>
+          </a:effectRef>
+          <a:fontRef idx="minor">
+            <a:schemeClr val="lt1"/>
+          </a:fontRef>
+        </p:style>
+        <p:txBody>
+          <a:bodyPr rtlCol="0" anchor="ctr"/>
+          <a:lstStyle/>
+          <a:p>
+            <a:pPr algn="ctr"/>
+            <a:r>
+              <a:rPr lang="zh-CN" altLang="en-US" sz="1013" b="1" dirty="0">
+                <a:solidFill>
+                  <a:schemeClr val="tx1"/>
+                </a:solidFill>
+              </a:rPr>
+              <a:t>映射</a:t>
+            </a:r>
+            <a:endParaRPr lang="en-US" altLang="zh-CN" sz="1013" b="1" dirty="0">
+              <a:solidFill>
+                <a:schemeClr val="tx1"/>
+              </a:solidFill>
+            </a:endParaRPr>
+          </a:p>
+        </p:txBody>
+      </p:sp>
+      <p:sp>
+        <p:nvSpPr>
+          <p:cNvPr id="20" name="流程图: 过程 19">
+            <a:extLst>
+              <a:ext uri="{FF2B5EF4-FFF2-40B4-BE49-F238E27FC236}">
+                <a16:creationId xmlns:a16="http://schemas.microsoft.com/office/drawing/2014/main" id="{3628704D-FA46-62A5-55A9-87E42EB96C49}"/>
+              </a:ext>
+            </a:extLst>
+          </p:cNvPr>
+          <p:cNvSpPr/>
+          <p:nvPr/>
+        </p:nvSpPr>
+        <p:spPr>
+          <a:xfrm>
+            <a:off x="6185850" y="586012"/>
+            <a:ext cx="1926857" cy="248209"/>
+          </a:xfrm>
+          <a:prstGeom prst="flowChartProcess">
+            <a:avLst/>
+          </a:prstGeom>
+          <a:solidFill>
+            <a:schemeClr val="accent1">
+              <a:lumMod val="60000"/>
+              <a:lumOff val="40000"/>
+            </a:schemeClr>
+          </a:solidFill>
+        </p:spPr>
+        <p:style>
+          <a:lnRef idx="2">
+            <a:schemeClr val="accent1">
+              <a:shade val="15000"/>
+            </a:schemeClr>
+          </a:lnRef>
+          <a:fillRef idx="1">
+            <a:schemeClr val="accent1"/>
+          </a:fillRef>
+          <a:effectRef idx="0">
+            <a:schemeClr val="accent1"/>
+          </a:effectRef>
+          <a:fontRef idx="minor">
+            <a:schemeClr val="lt1"/>
+          </a:fontRef>
+        </p:style>
+        <p:txBody>
+          <a:bodyPr rtlCol="0" anchor="ctr"/>
+          <a:lstStyle/>
+          <a:p>
+            <a:pPr algn="ctr"/>
+            <a:r>
+              <a:rPr lang="en-US" altLang="zh-CN" sz="1013" b="1" dirty="0">
+                <a:solidFill>
+                  <a:schemeClr val="tx1"/>
+                </a:solidFill>
+              </a:rPr>
+              <a:t>host(...), </a:t>
+            </a:r>
+            <a:r>
+              <a:rPr lang="en-US" altLang="zh-CN" sz="1013" b="1" dirty="0" err="1">
+                <a:solidFill>
+                  <a:schemeClr val="tx1"/>
+                </a:solidFill>
+              </a:rPr>
+              <a:t>hacl</a:t>
+            </a:r>
+            <a:r>
+              <a:rPr lang="en-US" altLang="zh-CN" sz="1013" b="1" dirty="0">
+                <a:solidFill>
+                  <a:schemeClr val="tx1"/>
+                </a:solidFill>
+              </a:rPr>
+              <a:t>(...)</a:t>
+            </a:r>
+            <a:endParaRPr lang="zh-CN" altLang="en-US" sz="1013" b="1" dirty="0">
+              <a:solidFill>
+                <a:schemeClr val="tx1"/>
+              </a:solidFill>
+            </a:endParaRPr>
+          </a:p>
+        </p:txBody>
+      </p:sp>
+      <p:sp>
+        <p:nvSpPr>
+          <p:cNvPr id="21" name="流程图: 过程 20">
+            <a:extLst>
+              <a:ext uri="{FF2B5EF4-FFF2-40B4-BE49-F238E27FC236}">
+                <a16:creationId xmlns:a16="http://schemas.microsoft.com/office/drawing/2014/main" id="{457F2FB8-92A1-5F47-370B-450C3E346266}"/>
+              </a:ext>
+            </a:extLst>
+          </p:cNvPr>
+          <p:cNvSpPr/>
+          <p:nvPr/>
+        </p:nvSpPr>
+        <p:spPr>
+          <a:xfrm>
+            <a:off x="1118518" y="154770"/>
+            <a:ext cx="836152" cy="259761"/>
+          </a:xfrm>
+          <a:prstGeom prst="flowChartProcess">
+            <a:avLst/>
+          </a:prstGeom>
+          <a:solidFill>
+            <a:schemeClr val="accent3">
+              <a:lumMod val="40000"/>
+              <a:lumOff val="60000"/>
+            </a:schemeClr>
+          </a:solidFill>
+        </p:spPr>
+        <p:style>
+          <a:lnRef idx="2">
+            <a:schemeClr val="accent1">
+              <a:shade val="15000"/>
+            </a:schemeClr>
+          </a:lnRef>
+          <a:fillRef idx="1">
+            <a:schemeClr val="accent1"/>
+          </a:fillRef>
+          <a:effectRef idx="0">
+            <a:schemeClr val="accent1"/>
+          </a:effectRef>
+          <a:fontRef idx="minor">
+            <a:schemeClr val="lt1"/>
+          </a:fontRef>
+        </p:style>
+        <p:txBody>
+          <a:bodyPr rtlCol="0" anchor="ctr"/>
+          <a:lstStyle/>
+          <a:p>
+            <a:pPr algn="ctr"/>
+            <a:r>
+              <a:rPr lang="en-US" altLang="zh-CN" sz="1013" b="1" dirty="0">
+                <a:solidFill>
+                  <a:schemeClr val="tx1"/>
+                </a:solidFill>
+              </a:rPr>
+              <a:t>ROS2 </a:t>
+            </a:r>
+            <a:r>
+              <a:rPr lang="zh-CN" altLang="en-US" sz="1013" b="1" dirty="0">
+                <a:solidFill>
+                  <a:schemeClr val="tx1"/>
+                </a:solidFill>
+              </a:rPr>
+              <a:t>对象</a:t>
+            </a:r>
+            <a:endParaRPr lang="en-US" altLang="zh-CN" sz="1013" b="1" dirty="0">
+              <a:solidFill>
+                <a:schemeClr val="tx1"/>
+              </a:solidFill>
+            </a:endParaRPr>
+          </a:p>
+        </p:txBody>
+      </p:sp>
+      <p:sp>
+        <p:nvSpPr>
+          <p:cNvPr id="22" name="流程图: 过程 21">
+            <a:extLst>
+              <a:ext uri="{FF2B5EF4-FFF2-40B4-BE49-F238E27FC236}">
+                <a16:creationId xmlns:a16="http://schemas.microsoft.com/office/drawing/2014/main" id="{1E7D4301-0767-C742-6E2E-90F10A50979D}"/>
+              </a:ext>
+            </a:extLst>
+          </p:cNvPr>
+          <p:cNvSpPr/>
+          <p:nvPr/>
+        </p:nvSpPr>
+        <p:spPr>
+          <a:xfrm>
+            <a:off x="6556472" y="154881"/>
+            <a:ext cx="1185611" cy="248209"/>
+          </a:xfrm>
+          <a:prstGeom prst="flowChartProcess">
+            <a:avLst/>
+          </a:prstGeom>
+          <a:solidFill>
+            <a:schemeClr val="accent1">
+              <a:lumMod val="60000"/>
+              <a:lumOff val="40000"/>
+            </a:schemeClr>
+          </a:solidFill>
+        </p:spPr>
+        <p:style>
+          <a:lnRef idx="2">
+            <a:schemeClr val="accent1">
+              <a:shade val="15000"/>
+            </a:schemeClr>
+          </a:lnRef>
+          <a:fillRef idx="1">
+            <a:schemeClr val="accent1"/>
+          </a:fillRef>
+          <a:effectRef idx="0">
+            <a:schemeClr val="accent1"/>
+          </a:effectRef>
+          <a:fontRef idx="minor">
+            <a:schemeClr val="lt1"/>
+          </a:fontRef>
+        </p:style>
+        <p:txBody>
+          <a:bodyPr rtlCol="0" anchor="ctr"/>
+          <a:lstStyle/>
+          <a:p>
+            <a:pPr algn="ctr"/>
+            <a:r>
+              <a:rPr lang="en-US" altLang="zh-CN" sz="1013" b="1" dirty="0">
+                <a:solidFill>
+                  <a:schemeClr val="tx1"/>
+                </a:solidFill>
+              </a:rPr>
+              <a:t>XSB</a:t>
+            </a:r>
+            <a:r>
+              <a:rPr lang="zh-CN" altLang="en-US" sz="1013" b="1" dirty="0">
+                <a:solidFill>
+                  <a:schemeClr val="tx1"/>
+                </a:solidFill>
+              </a:rPr>
+              <a:t>元素</a:t>
+            </a:r>
+          </a:p>
+        </p:txBody>
+      </p:sp>
+      <p:cxnSp>
+        <p:nvCxnSpPr>
+          <p:cNvPr id="19" name="直接箭头连接符 18">
+            <a:extLst>
+              <a:ext uri="{FF2B5EF4-FFF2-40B4-BE49-F238E27FC236}">
+                <a16:creationId xmlns:a16="http://schemas.microsoft.com/office/drawing/2014/main" id="{1B0FFE05-C401-CE54-59F2-A231B92C6053}"/>
+              </a:ext>
+            </a:extLst>
+          </p:cNvPr>
+          <p:cNvCxnSpPr>
+            <a:cxnSpLocks/>
+            <a:stCxn id="4" idx="3"/>
+            <a:endCxn id="20" idx="1"/>
+          </p:cNvCxnSpPr>
+          <p:nvPr/>
+        </p:nvCxnSpPr>
+        <p:spPr>
+          <a:xfrm>
+            <a:off x="2157715" y="710117"/>
+            <a:ext cx="4028135" cy="0"/>
+          </a:xfrm>
+          <a:prstGeom prst="straightConnector1">
+            <a:avLst/>
+          </a:prstGeom>
+          <a:ln w="38100">
+            <a:tailEnd type="triangle"/>
+          </a:ln>
+        </p:spPr>
+        <p:style>
+          <a:lnRef idx="1">
+            <a:schemeClr val="accent1"/>
+          </a:lnRef>
+          <a:fillRef idx="0">
+            <a:schemeClr val="accent1"/>
+          </a:fillRef>
+          <a:effectRef idx="0">
+            <a:schemeClr val="accent1"/>
+          </a:effectRef>
+          <a:fontRef idx="minor">
+            <a:schemeClr val="tx1"/>
+          </a:fontRef>
+        </p:style>
+      </p:cxnSp>
+      <p:sp>
+        <p:nvSpPr>
+          <p:cNvPr id="24" name="文本框 23">
+            <a:extLst>
+              <a:ext uri="{FF2B5EF4-FFF2-40B4-BE49-F238E27FC236}">
+                <a16:creationId xmlns:a16="http://schemas.microsoft.com/office/drawing/2014/main" id="{FA7015E4-F76F-C33F-EAF4-15EFF399D841}"/>
+              </a:ext>
+            </a:extLst>
+          </p:cNvPr>
+          <p:cNvSpPr txBox="1"/>
+          <p:nvPr/>
+        </p:nvSpPr>
+        <p:spPr>
+          <a:xfrm>
+            <a:off x="3676185" y="483201"/>
+            <a:ext cx="1019831" cy="248209"/>
+          </a:xfrm>
+          <a:prstGeom prst="rect">
+            <a:avLst/>
+          </a:prstGeom>
+          <a:noFill/>
+        </p:spPr>
+        <p:txBody>
+          <a:bodyPr wrap="none" rtlCol="0">
+            <a:spAutoFit/>
+          </a:bodyPr>
+          <a:lstStyle/>
+          <a:p>
+            <a:r>
+              <a:rPr lang="zh-CN" altLang="en-US" sz="1013" b="1" dirty="0"/>
+              <a:t>主机</a:t>
+            </a:r>
+            <a:r>
+              <a:rPr lang="en-US" altLang="zh-CN" sz="1013" b="1" dirty="0"/>
+              <a:t>/</a:t>
+            </a:r>
+            <a:r>
+              <a:rPr lang="zh-CN" altLang="en-US" sz="1013" b="1" dirty="0"/>
+              <a:t>可达关系</a:t>
+            </a:r>
+            <a:endParaRPr lang="en-US" altLang="zh-CN" sz="1013" b="1" dirty="0"/>
+          </a:p>
+        </p:txBody>
+      </p:sp>
+      <p:sp>
+        <p:nvSpPr>
+          <p:cNvPr id="25" name="文本框 24">
+            <a:extLst>
+              <a:ext uri="{FF2B5EF4-FFF2-40B4-BE49-F238E27FC236}">
+                <a16:creationId xmlns:a16="http://schemas.microsoft.com/office/drawing/2014/main" id="{5ADEDEA7-B4DE-16F2-BAC7-8EF8F611CD3E}"/>
+              </a:ext>
+            </a:extLst>
+          </p:cNvPr>
+          <p:cNvSpPr txBox="1"/>
+          <p:nvPr/>
+        </p:nvSpPr>
+        <p:spPr>
+          <a:xfrm>
+            <a:off x="3760847" y="974435"/>
+            <a:ext cx="704039" cy="248209"/>
+          </a:xfrm>
+          <a:prstGeom prst="rect">
+            <a:avLst/>
+          </a:prstGeom>
+          <a:noFill/>
+        </p:spPr>
+        <p:txBody>
+          <a:bodyPr wrap="none" rtlCol="0">
+            <a:spAutoFit/>
+          </a:bodyPr>
+          <a:lstStyle/>
+          <a:p>
+            <a:r>
+              <a:rPr lang="zh-CN" altLang="en-US" sz="1013" b="1" dirty="0"/>
+              <a:t>话题事实</a:t>
+            </a:r>
+            <a:endParaRPr lang="en-US" altLang="zh-CN" sz="1013" b="1" dirty="0"/>
+          </a:p>
+        </p:txBody>
+      </p:sp>
+      <p:cxnSp>
+        <p:nvCxnSpPr>
+          <p:cNvPr id="26" name="直接箭头连接符 25">
+            <a:extLst>
+              <a:ext uri="{FF2B5EF4-FFF2-40B4-BE49-F238E27FC236}">
+                <a16:creationId xmlns:a16="http://schemas.microsoft.com/office/drawing/2014/main" id="{B70050DA-83EA-146D-BA88-877C61F37B74}"/>
+              </a:ext>
+            </a:extLst>
+          </p:cNvPr>
+          <p:cNvCxnSpPr>
+            <a:cxnSpLocks/>
+            <a:stCxn id="2" idx="3"/>
+            <a:endCxn id="18" idx="1"/>
+          </p:cNvCxnSpPr>
+          <p:nvPr/>
+        </p:nvCxnSpPr>
+        <p:spPr>
+          <a:xfrm>
+            <a:off x="2157715" y="1215670"/>
+            <a:ext cx="4028135" cy="0"/>
+          </a:xfrm>
+          <a:prstGeom prst="straightConnector1">
+            <a:avLst/>
+          </a:prstGeom>
+          <a:ln w="38100">
+            <a:tailEnd type="triangle"/>
+          </a:ln>
+        </p:spPr>
+        <p:style>
+          <a:lnRef idx="1">
+            <a:schemeClr val="accent1"/>
+          </a:lnRef>
+          <a:fillRef idx="0">
+            <a:schemeClr val="accent1"/>
+          </a:fillRef>
+          <a:effectRef idx="0">
+            <a:schemeClr val="accent1"/>
+          </a:effectRef>
+          <a:fontRef idx="minor">
+            <a:schemeClr val="tx1"/>
+          </a:fontRef>
+        </p:style>
+      </p:cxnSp>
+      <p:cxnSp>
+        <p:nvCxnSpPr>
+          <p:cNvPr id="30" name="直接箭头连接符 29">
+            <a:extLst>
+              <a:ext uri="{FF2B5EF4-FFF2-40B4-BE49-F238E27FC236}">
+                <a16:creationId xmlns:a16="http://schemas.microsoft.com/office/drawing/2014/main" id="{8C288136-A0CF-3F72-654E-ED877E807DED}"/>
+              </a:ext>
+            </a:extLst>
+          </p:cNvPr>
+          <p:cNvCxnSpPr>
+            <a:cxnSpLocks/>
+            <a:stCxn id="3" idx="3"/>
+            <a:endCxn id="36" idx="1"/>
+          </p:cNvCxnSpPr>
+          <p:nvPr/>
+        </p:nvCxnSpPr>
+        <p:spPr>
+          <a:xfrm flipV="1">
+            <a:off x="2166321" y="1775167"/>
+            <a:ext cx="4065767" cy="2265"/>
+          </a:xfrm>
+          <a:prstGeom prst="straightConnector1">
+            <a:avLst/>
+          </a:prstGeom>
+          <a:ln w="38100">
+            <a:tailEnd type="triangle"/>
+          </a:ln>
+        </p:spPr>
+        <p:style>
+          <a:lnRef idx="1">
+            <a:schemeClr val="accent1"/>
+          </a:lnRef>
+          <a:fillRef idx="0">
+            <a:schemeClr val="accent1"/>
+          </a:fillRef>
+          <a:effectRef idx="0">
+            <a:schemeClr val="accent1"/>
+          </a:effectRef>
+          <a:fontRef idx="minor">
+            <a:schemeClr val="tx1"/>
+          </a:fontRef>
+        </p:style>
+      </p:cxnSp>
+      <p:sp>
+        <p:nvSpPr>
+          <p:cNvPr id="31" name="文本框 30">
+            <a:extLst>
+              <a:ext uri="{FF2B5EF4-FFF2-40B4-BE49-F238E27FC236}">
+                <a16:creationId xmlns:a16="http://schemas.microsoft.com/office/drawing/2014/main" id="{DFFB0C49-F8BC-3D33-2BCF-34572B203C8A}"/>
+              </a:ext>
+            </a:extLst>
+          </p:cNvPr>
+          <p:cNvSpPr txBox="1"/>
+          <p:nvPr/>
+        </p:nvSpPr>
+        <p:spPr>
+          <a:xfrm>
+            <a:off x="3778706" y="1478963"/>
+            <a:ext cx="704039" cy="248209"/>
+          </a:xfrm>
+          <a:prstGeom prst="rect">
+            <a:avLst/>
+          </a:prstGeom>
+          <a:noFill/>
+        </p:spPr>
+        <p:txBody>
+          <a:bodyPr wrap="none" rtlCol="0">
+            <a:spAutoFit/>
+          </a:bodyPr>
+          <a:lstStyle/>
+          <a:p>
+            <a:r>
+              <a:rPr lang="zh-CN" altLang="en-US" sz="1013" b="1" dirty="0"/>
+              <a:t>通信关系</a:t>
+            </a:r>
+            <a:endParaRPr lang="en-US" altLang="zh-CN" sz="1013" b="1" dirty="0"/>
+          </a:p>
+        </p:txBody>
+      </p:sp>
+      <p:cxnSp>
+        <p:nvCxnSpPr>
+          <p:cNvPr id="37" name="直接箭头连接符 36">
+            <a:extLst>
+              <a:ext uri="{FF2B5EF4-FFF2-40B4-BE49-F238E27FC236}">
+                <a16:creationId xmlns:a16="http://schemas.microsoft.com/office/drawing/2014/main" id="{4AC4E2E6-A113-16ED-AB6E-2EF643377951}"/>
+              </a:ext>
+            </a:extLst>
+          </p:cNvPr>
+          <p:cNvCxnSpPr>
+            <a:cxnSpLocks/>
+            <a:stCxn id="9" idx="3"/>
+            <a:endCxn id="55" idx="1"/>
+          </p:cNvCxnSpPr>
+          <p:nvPr/>
+        </p:nvCxnSpPr>
+        <p:spPr>
+          <a:xfrm>
+            <a:off x="2166321" y="3302283"/>
+            <a:ext cx="4070406" cy="0"/>
+          </a:xfrm>
+          <a:prstGeom prst="straightConnector1">
+            <a:avLst/>
+          </a:prstGeom>
+          <a:ln w="38100">
+            <a:tailEnd type="triangle"/>
+          </a:ln>
+        </p:spPr>
+        <p:style>
+          <a:lnRef idx="1">
+            <a:schemeClr val="accent1"/>
+          </a:lnRef>
+          <a:fillRef idx="0">
+            <a:schemeClr val="accent1"/>
+          </a:fillRef>
+          <a:effectRef idx="0">
+            <a:schemeClr val="accent1"/>
+          </a:effectRef>
+          <a:fontRef idx="minor">
+            <a:schemeClr val="tx1"/>
+          </a:fontRef>
+        </p:style>
+      </p:cxnSp>
+      <p:sp>
+        <p:nvSpPr>
+          <p:cNvPr id="39" name="文本框 38">
+            <a:extLst>
+              <a:ext uri="{FF2B5EF4-FFF2-40B4-BE49-F238E27FC236}">
+                <a16:creationId xmlns:a16="http://schemas.microsoft.com/office/drawing/2014/main" id="{3C5A540D-2459-CF5E-3815-344AF2778B59}"/>
+              </a:ext>
+            </a:extLst>
+          </p:cNvPr>
+          <p:cNvSpPr txBox="1"/>
+          <p:nvPr/>
+        </p:nvSpPr>
+        <p:spPr>
+          <a:xfrm>
+            <a:off x="3735163" y="3014888"/>
+            <a:ext cx="1599651" cy="248209"/>
+          </a:xfrm>
+          <a:prstGeom prst="rect">
+            <a:avLst/>
+          </a:prstGeom>
+          <a:noFill/>
+        </p:spPr>
+        <p:txBody>
+          <a:bodyPr wrap="square" rtlCol="0">
+            <a:spAutoFit/>
+          </a:bodyPr>
+          <a:lstStyle/>
+          <a:p>
+            <a:r>
+              <a:rPr lang="zh-CN" altLang="en-US" sz="1013" b="1" dirty="0"/>
+              <a:t>攻击规则</a:t>
+            </a:r>
+            <a:endParaRPr lang="en-US" altLang="zh-CN" sz="1013" b="1" dirty="0"/>
+          </a:p>
+        </p:txBody>
+      </p:sp>
+      <p:sp>
+        <p:nvSpPr>
+          <p:cNvPr id="41" name="文本框 40">
+            <a:extLst>
+              <a:ext uri="{FF2B5EF4-FFF2-40B4-BE49-F238E27FC236}">
+                <a16:creationId xmlns:a16="http://schemas.microsoft.com/office/drawing/2014/main" id="{41D2C6B3-5A8B-1AD9-5F44-E0DD5DD89252}"/>
+              </a:ext>
+            </a:extLst>
+          </p:cNvPr>
+          <p:cNvSpPr txBox="1"/>
+          <p:nvPr/>
+        </p:nvSpPr>
+        <p:spPr>
+          <a:xfrm>
+            <a:off x="3719851" y="3919330"/>
+            <a:ext cx="1211414" cy="248209"/>
+          </a:xfrm>
+          <a:prstGeom prst="rect">
+            <a:avLst/>
+          </a:prstGeom>
+          <a:noFill/>
+        </p:spPr>
+        <p:txBody>
+          <a:bodyPr wrap="square" rtlCol="0">
+            <a:spAutoFit/>
+          </a:bodyPr>
+          <a:lstStyle/>
+          <a:p>
+            <a:r>
+              <a:rPr lang="zh-CN" altLang="en-US" sz="1013" b="1" dirty="0"/>
+              <a:t>查询结论</a:t>
+            </a:r>
+            <a:endParaRPr lang="en-US" altLang="zh-CN" sz="1013" b="1" dirty="0"/>
+          </a:p>
+        </p:txBody>
+      </p:sp>
+      <p:cxnSp>
+        <p:nvCxnSpPr>
+          <p:cNvPr id="58" name="直接箭头连接符 57">
+            <a:extLst>
+              <a:ext uri="{FF2B5EF4-FFF2-40B4-BE49-F238E27FC236}">
+                <a16:creationId xmlns:a16="http://schemas.microsoft.com/office/drawing/2014/main" id="{864F8175-3DD6-19BA-2076-40AC5927B239}"/>
+              </a:ext>
+            </a:extLst>
+          </p:cNvPr>
+          <p:cNvCxnSpPr>
+            <a:cxnSpLocks/>
+            <a:stCxn id="13" idx="3"/>
+            <a:endCxn id="61" idx="1"/>
+          </p:cNvCxnSpPr>
+          <p:nvPr/>
+        </p:nvCxnSpPr>
+        <p:spPr>
+          <a:xfrm>
+            <a:off x="2175809" y="4167539"/>
+            <a:ext cx="4071717" cy="7598"/>
+          </a:xfrm>
+          <a:prstGeom prst="straightConnector1">
+            <a:avLst/>
+          </a:prstGeom>
+          <a:ln w="38100">
+            <a:tailEnd type="triangle"/>
+          </a:ln>
+        </p:spPr>
+        <p:style>
+          <a:lnRef idx="1">
+            <a:schemeClr val="accent1"/>
+          </a:lnRef>
+          <a:fillRef idx="0">
+            <a:schemeClr val="accent1"/>
+          </a:fillRef>
+          <a:effectRef idx="0">
+            <a:schemeClr val="accent1"/>
+          </a:effectRef>
+          <a:fontRef idx="minor">
+            <a:schemeClr val="tx1"/>
+          </a:fontRef>
+        </p:style>
+      </p:cxnSp>
+      <p:sp>
+        <p:nvSpPr>
+          <p:cNvPr id="2" name="流程图: 过程 1">
+            <a:extLst>
+              <a:ext uri="{FF2B5EF4-FFF2-40B4-BE49-F238E27FC236}">
+                <a16:creationId xmlns:a16="http://schemas.microsoft.com/office/drawing/2014/main" id="{9AF6DB0C-8F28-CD33-D8FC-442887960095}"/>
+              </a:ext>
+            </a:extLst>
+          </p:cNvPr>
+          <p:cNvSpPr/>
+          <p:nvPr/>
+        </p:nvSpPr>
+        <p:spPr>
+          <a:xfrm>
+            <a:off x="1037637" y="1033720"/>
+            <a:ext cx="1120078" cy="363900"/>
+          </a:xfrm>
+          <a:prstGeom prst="flowChartProcess">
+            <a:avLst/>
+          </a:prstGeom>
+          <a:solidFill>
+            <a:schemeClr val="accent1">
+              <a:lumMod val="60000"/>
+              <a:lumOff val="40000"/>
+            </a:schemeClr>
+          </a:solidFill>
+        </p:spPr>
+        <p:style>
+          <a:lnRef idx="2">
+            <a:schemeClr val="accent1">
+              <a:shade val="15000"/>
+            </a:schemeClr>
+          </a:lnRef>
+          <a:fillRef idx="1">
+            <a:schemeClr val="accent1"/>
+          </a:fillRef>
+          <a:effectRef idx="0">
+            <a:schemeClr val="accent1"/>
+          </a:effectRef>
+          <a:fontRef idx="minor">
+            <a:schemeClr val="lt1"/>
+          </a:fontRef>
+        </p:style>
+        <p:txBody>
+          <a:bodyPr rtlCol="0" anchor="ctr"/>
+          <a:lstStyle/>
+          <a:p>
+            <a:pPr algn="ctr"/>
+            <a:r>
+              <a:rPr lang="en-US" altLang="zh-CN" sz="1013" b="1" dirty="0">
+                <a:solidFill>
+                  <a:schemeClr val="tx1"/>
+                </a:solidFill>
+              </a:rPr>
+              <a:t>ROS2 topic</a:t>
+            </a:r>
+          </a:p>
+          <a:p>
+            <a:pPr algn="ctr"/>
+            <a:r>
+              <a:rPr lang="en-US" altLang="zh-CN" sz="1013" b="1" dirty="0">
+                <a:solidFill>
+                  <a:schemeClr val="tx1"/>
+                </a:solidFill>
+              </a:rPr>
+              <a:t>(…)</a:t>
+            </a:r>
+            <a:endParaRPr lang="zh-CN" altLang="en-US" sz="1013" b="1" dirty="0">
+              <a:solidFill>
+                <a:schemeClr val="tx1"/>
+              </a:solidFill>
+            </a:endParaRPr>
+          </a:p>
+        </p:txBody>
+      </p:sp>
+      <p:sp>
+        <p:nvSpPr>
+          <p:cNvPr id="3" name="流程图: 过程 2">
+            <a:extLst>
+              <a:ext uri="{FF2B5EF4-FFF2-40B4-BE49-F238E27FC236}">
+                <a16:creationId xmlns:a16="http://schemas.microsoft.com/office/drawing/2014/main" id="{3F5C5C1F-3872-1088-91B6-20250D1A9BFA}"/>
+              </a:ext>
+            </a:extLst>
+          </p:cNvPr>
+          <p:cNvSpPr/>
+          <p:nvPr/>
+        </p:nvSpPr>
+        <p:spPr>
+          <a:xfrm>
+            <a:off x="1046243" y="1595482"/>
+            <a:ext cx="1120078" cy="363900"/>
+          </a:xfrm>
+          <a:prstGeom prst="flowChartProcess">
+            <a:avLst/>
+          </a:prstGeom>
+          <a:solidFill>
+            <a:schemeClr val="accent1">
+              <a:lumMod val="60000"/>
+              <a:lumOff val="40000"/>
+            </a:schemeClr>
+          </a:solidFill>
+        </p:spPr>
+        <p:style>
+          <a:lnRef idx="2">
+            <a:schemeClr val="accent1">
+              <a:shade val="15000"/>
+            </a:schemeClr>
+          </a:lnRef>
+          <a:fillRef idx="1">
+            <a:schemeClr val="accent1"/>
+          </a:fillRef>
+          <a:effectRef idx="0">
+            <a:schemeClr val="accent1"/>
+          </a:effectRef>
+          <a:fontRef idx="minor">
+            <a:schemeClr val="lt1"/>
+          </a:fontRef>
+        </p:style>
+        <p:txBody>
+          <a:bodyPr rtlCol="0" anchor="ctr"/>
+          <a:lstStyle/>
+          <a:p>
+            <a:pPr algn="ctr"/>
+            <a:r>
+              <a:rPr lang="zh-CN" altLang="en-US" sz="1013" b="1" dirty="0">
+                <a:solidFill>
+                  <a:schemeClr val="tx1"/>
+                </a:solidFill>
+              </a:rPr>
+              <a:t>发布者</a:t>
+            </a:r>
+            <a:r>
+              <a:rPr lang="en-US" altLang="zh-CN" sz="1013" b="1" dirty="0">
+                <a:solidFill>
+                  <a:schemeClr val="tx1"/>
+                </a:solidFill>
+              </a:rPr>
+              <a:t>/</a:t>
+            </a:r>
+            <a:r>
+              <a:rPr lang="zh-CN" altLang="en-US" sz="1013" b="1" dirty="0">
+                <a:solidFill>
+                  <a:schemeClr val="tx1"/>
+                </a:solidFill>
+              </a:rPr>
+              <a:t>订阅者</a:t>
+            </a:r>
+            <a:endParaRPr lang="en-US" altLang="zh-CN" sz="1013" b="1" dirty="0">
+              <a:solidFill>
+                <a:schemeClr val="tx1"/>
+              </a:solidFill>
+            </a:endParaRPr>
+          </a:p>
+          <a:p>
+            <a:pPr algn="ctr"/>
+            <a:r>
+              <a:rPr lang="en-US" altLang="zh-CN" sz="1013" b="1" dirty="0">
+                <a:solidFill>
+                  <a:schemeClr val="tx1"/>
+                </a:solidFill>
+              </a:rPr>
+              <a:t>(…)</a:t>
+            </a:r>
+            <a:endParaRPr lang="zh-CN" altLang="en-US" sz="1013" b="1" dirty="0">
+              <a:solidFill>
+                <a:schemeClr val="tx1"/>
+              </a:solidFill>
+            </a:endParaRPr>
+          </a:p>
+        </p:txBody>
+      </p:sp>
+      <p:sp>
+        <p:nvSpPr>
+          <p:cNvPr id="7" name="流程图: 过程 6">
+            <a:extLst>
+              <a:ext uri="{FF2B5EF4-FFF2-40B4-BE49-F238E27FC236}">
+                <a16:creationId xmlns:a16="http://schemas.microsoft.com/office/drawing/2014/main" id="{78671B01-7174-F59D-392D-4E80F7D4D1C6}"/>
+              </a:ext>
+            </a:extLst>
+          </p:cNvPr>
+          <p:cNvSpPr/>
+          <p:nvPr/>
+        </p:nvSpPr>
+        <p:spPr>
+          <a:xfrm>
+            <a:off x="1046243" y="2136519"/>
+            <a:ext cx="1120078" cy="248209"/>
+          </a:xfrm>
+          <a:prstGeom prst="flowChartProcess">
+            <a:avLst/>
+          </a:prstGeom>
+          <a:solidFill>
+            <a:schemeClr val="accent1">
+              <a:lumMod val="60000"/>
+              <a:lumOff val="40000"/>
+            </a:schemeClr>
+          </a:solidFill>
+        </p:spPr>
+        <p:style>
+          <a:lnRef idx="2">
+            <a:schemeClr val="accent1">
+              <a:shade val="15000"/>
+            </a:schemeClr>
+          </a:lnRef>
+          <a:fillRef idx="1">
+            <a:schemeClr val="accent1"/>
+          </a:fillRef>
+          <a:effectRef idx="0">
+            <a:schemeClr val="accent1"/>
+          </a:effectRef>
+          <a:fontRef idx="minor">
+            <a:schemeClr val="lt1"/>
+          </a:fontRef>
+        </p:style>
+        <p:txBody>
+          <a:bodyPr rtlCol="0" anchor="ctr"/>
+          <a:lstStyle/>
+          <a:p>
+            <a:pPr algn="ctr"/>
+            <a:r>
+              <a:rPr lang="zh-CN" altLang="en-US" sz="1013" b="1" dirty="0">
+                <a:solidFill>
+                  <a:schemeClr val="tx1"/>
+                </a:solidFill>
+              </a:rPr>
+              <a:t>显示链</a:t>
+            </a:r>
+          </a:p>
+        </p:txBody>
+      </p:sp>
+      <p:sp>
+        <p:nvSpPr>
+          <p:cNvPr id="9" name="流程图: 过程 8">
+            <a:extLst>
+              <a:ext uri="{FF2B5EF4-FFF2-40B4-BE49-F238E27FC236}">
+                <a16:creationId xmlns:a16="http://schemas.microsoft.com/office/drawing/2014/main" id="{32097377-34CC-691A-EFBE-6021A0637415}"/>
+              </a:ext>
+            </a:extLst>
+          </p:cNvPr>
+          <p:cNvSpPr/>
+          <p:nvPr/>
+        </p:nvSpPr>
+        <p:spPr>
+          <a:xfrm>
+            <a:off x="1046243" y="3178178"/>
+            <a:ext cx="1120078" cy="248209"/>
+          </a:xfrm>
+          <a:prstGeom prst="flowChartProcess">
+            <a:avLst/>
+          </a:prstGeom>
+          <a:solidFill>
+            <a:schemeClr val="accent1">
+              <a:lumMod val="60000"/>
+              <a:lumOff val="40000"/>
+            </a:schemeClr>
+          </a:solidFill>
+        </p:spPr>
+        <p:style>
+          <a:lnRef idx="2">
+            <a:schemeClr val="accent1">
+              <a:shade val="15000"/>
+            </a:schemeClr>
+          </a:lnRef>
+          <a:fillRef idx="1">
+            <a:schemeClr val="accent1"/>
+          </a:fillRef>
+          <a:effectRef idx="0">
+            <a:schemeClr val="accent1"/>
+          </a:effectRef>
+          <a:fontRef idx="minor">
+            <a:schemeClr val="lt1"/>
+          </a:fontRef>
+        </p:style>
+        <p:txBody>
+          <a:bodyPr rtlCol="0" anchor="ctr"/>
+          <a:lstStyle/>
+          <a:p>
+            <a:pPr algn="ctr"/>
+            <a:r>
+              <a:rPr lang="zh-CN" altLang="en-US" sz="1013" b="1" dirty="0">
+                <a:solidFill>
+                  <a:schemeClr val="tx1"/>
+                </a:solidFill>
+              </a:rPr>
+              <a:t>攻击动作</a:t>
+            </a:r>
+          </a:p>
+        </p:txBody>
+      </p:sp>
+      <p:sp>
+        <p:nvSpPr>
+          <p:cNvPr id="13" name="流程图: 过程 12">
+            <a:extLst>
+              <a:ext uri="{FF2B5EF4-FFF2-40B4-BE49-F238E27FC236}">
+                <a16:creationId xmlns:a16="http://schemas.microsoft.com/office/drawing/2014/main" id="{4F538C0F-0B05-9617-4B56-3CAA0445516A}"/>
+              </a:ext>
+            </a:extLst>
+          </p:cNvPr>
+          <p:cNvSpPr/>
+          <p:nvPr/>
+        </p:nvSpPr>
+        <p:spPr>
+          <a:xfrm>
+            <a:off x="1055731" y="4043434"/>
+            <a:ext cx="1120078" cy="248209"/>
+          </a:xfrm>
+          <a:prstGeom prst="flowChartProcess">
+            <a:avLst/>
+          </a:prstGeom>
+          <a:solidFill>
+            <a:schemeClr val="accent1">
+              <a:lumMod val="60000"/>
+              <a:lumOff val="40000"/>
+            </a:schemeClr>
+          </a:solidFill>
+        </p:spPr>
+        <p:style>
+          <a:lnRef idx="2">
+            <a:schemeClr val="accent1">
+              <a:shade val="15000"/>
+            </a:schemeClr>
+          </a:lnRef>
+          <a:fillRef idx="1">
+            <a:schemeClr val="accent1"/>
+          </a:fillRef>
+          <a:effectRef idx="0">
+            <a:schemeClr val="accent1"/>
+          </a:effectRef>
+          <a:fontRef idx="minor">
+            <a:schemeClr val="lt1"/>
+          </a:fontRef>
+        </p:style>
+        <p:txBody>
+          <a:bodyPr rtlCol="0" anchor="ctr"/>
+          <a:lstStyle/>
+          <a:p>
+            <a:pPr algn="ctr"/>
+            <a:r>
+              <a:rPr lang="zh-CN" altLang="en-US" sz="1013" b="1" dirty="0">
+                <a:solidFill>
+                  <a:schemeClr val="tx1"/>
+                </a:solidFill>
+              </a:rPr>
+              <a:t>攻击结果</a:t>
+            </a:r>
+          </a:p>
+        </p:txBody>
+      </p:sp>
+      <p:sp>
+        <p:nvSpPr>
+          <p:cNvPr id="18" name="流程图: 过程 17">
+            <a:extLst>
+              <a:ext uri="{FF2B5EF4-FFF2-40B4-BE49-F238E27FC236}">
+                <a16:creationId xmlns:a16="http://schemas.microsoft.com/office/drawing/2014/main" id="{5614162B-82C9-01B0-77A4-D4AEA6657412}"/>
+              </a:ext>
+            </a:extLst>
+          </p:cNvPr>
+          <p:cNvSpPr/>
+          <p:nvPr/>
+        </p:nvSpPr>
+        <p:spPr>
+          <a:xfrm>
+            <a:off x="6185850" y="1091565"/>
+            <a:ext cx="1926857" cy="248209"/>
+          </a:xfrm>
+          <a:prstGeom prst="flowChartProcess">
+            <a:avLst/>
+          </a:prstGeom>
+          <a:solidFill>
+            <a:schemeClr val="accent1">
+              <a:lumMod val="60000"/>
+              <a:lumOff val="40000"/>
+            </a:schemeClr>
+          </a:solidFill>
+        </p:spPr>
+        <p:style>
+          <a:lnRef idx="2">
+            <a:schemeClr val="accent1">
+              <a:shade val="15000"/>
+            </a:schemeClr>
+          </a:lnRef>
+          <a:fillRef idx="1">
+            <a:schemeClr val="accent1"/>
+          </a:fillRef>
+          <a:effectRef idx="0">
+            <a:schemeClr val="accent1"/>
+          </a:effectRef>
+          <a:fontRef idx="minor">
+            <a:schemeClr val="lt1"/>
+          </a:fontRef>
+        </p:style>
+        <p:txBody>
+          <a:bodyPr rtlCol="0" anchor="ctr"/>
+          <a:lstStyle/>
+          <a:p>
+            <a:pPr algn="ctr"/>
+            <a:r>
+              <a:rPr lang="en-US" altLang="zh-CN" sz="1013" b="1" dirty="0" err="1">
+                <a:solidFill>
+                  <a:schemeClr val="tx1"/>
+                </a:solidFill>
+              </a:rPr>
+              <a:t>rosTopic</a:t>
+            </a:r>
+            <a:r>
+              <a:rPr lang="en-US" altLang="zh-CN" sz="1013" b="1" dirty="0">
+                <a:solidFill>
+                  <a:schemeClr val="tx1"/>
+                </a:solidFill>
+              </a:rPr>
+              <a:t>(...), </a:t>
+            </a:r>
+            <a:r>
+              <a:rPr lang="en-US" altLang="zh-CN" sz="1013" b="1" dirty="0" err="1">
+                <a:solidFill>
+                  <a:schemeClr val="tx1"/>
+                </a:solidFill>
+              </a:rPr>
+              <a:t>messageType</a:t>
+            </a:r>
+            <a:r>
+              <a:rPr lang="en-US" altLang="zh-CN" sz="1013" b="1" dirty="0">
+                <a:solidFill>
+                  <a:schemeClr val="tx1"/>
+                </a:solidFill>
+              </a:rPr>
+              <a:t>(…)</a:t>
+            </a:r>
+            <a:endParaRPr lang="zh-CN" altLang="en-US" sz="1013" b="1" dirty="0">
+              <a:solidFill>
+                <a:schemeClr val="tx1"/>
+              </a:solidFill>
+            </a:endParaRPr>
+          </a:p>
+        </p:txBody>
+      </p:sp>
+      <p:sp>
+        <p:nvSpPr>
+          <p:cNvPr id="36" name="流程图: 过程 35">
+            <a:extLst>
+              <a:ext uri="{FF2B5EF4-FFF2-40B4-BE49-F238E27FC236}">
+                <a16:creationId xmlns:a16="http://schemas.microsoft.com/office/drawing/2014/main" id="{F16F3A73-C166-C4F9-93CF-0343727A47CF}"/>
+              </a:ext>
+            </a:extLst>
+          </p:cNvPr>
+          <p:cNvSpPr/>
+          <p:nvPr/>
+        </p:nvSpPr>
+        <p:spPr>
+          <a:xfrm>
+            <a:off x="6232088" y="1651062"/>
+            <a:ext cx="1926857" cy="248209"/>
+          </a:xfrm>
+          <a:prstGeom prst="flowChartProcess">
+            <a:avLst/>
+          </a:prstGeom>
+          <a:solidFill>
+            <a:schemeClr val="accent1">
+              <a:lumMod val="60000"/>
+              <a:lumOff val="40000"/>
+            </a:schemeClr>
+          </a:solidFill>
+        </p:spPr>
+        <p:style>
+          <a:lnRef idx="2">
+            <a:schemeClr val="accent1">
+              <a:shade val="15000"/>
+            </a:schemeClr>
+          </a:lnRef>
+          <a:fillRef idx="1">
+            <a:schemeClr val="accent1"/>
+          </a:fillRef>
+          <a:effectRef idx="0">
+            <a:schemeClr val="accent1"/>
+          </a:effectRef>
+          <a:fontRef idx="minor">
+            <a:schemeClr val="lt1"/>
+          </a:fontRef>
+        </p:style>
+        <p:txBody>
+          <a:bodyPr rtlCol="0" anchor="ctr"/>
+          <a:lstStyle/>
+          <a:p>
+            <a:pPr algn="ctr"/>
+            <a:r>
+              <a:rPr lang="en-US" altLang="zh-CN" sz="1013" b="1" dirty="0">
+                <a:solidFill>
+                  <a:schemeClr val="tx1"/>
+                </a:solidFill>
+              </a:rPr>
+              <a:t>publishes(...), subscribes(...)</a:t>
+            </a:r>
+            <a:endParaRPr lang="zh-CN" altLang="en-US" sz="1013" b="1" dirty="0">
+              <a:solidFill>
+                <a:schemeClr val="tx1"/>
+              </a:solidFill>
+            </a:endParaRPr>
+          </a:p>
+        </p:txBody>
+      </p:sp>
+      <p:sp>
+        <p:nvSpPr>
+          <p:cNvPr id="44" name="流程图: 过程 43">
+            <a:extLst>
+              <a:ext uri="{FF2B5EF4-FFF2-40B4-BE49-F238E27FC236}">
+                <a16:creationId xmlns:a16="http://schemas.microsoft.com/office/drawing/2014/main" id="{2CC3E7FE-9465-59AD-53AA-04046AA00588}"/>
+              </a:ext>
+            </a:extLst>
+          </p:cNvPr>
+          <p:cNvSpPr/>
+          <p:nvPr/>
+        </p:nvSpPr>
+        <p:spPr>
+          <a:xfrm>
+            <a:off x="6233398" y="2120525"/>
+            <a:ext cx="1926857" cy="248209"/>
+          </a:xfrm>
+          <a:prstGeom prst="flowChartProcess">
+            <a:avLst/>
+          </a:prstGeom>
+          <a:solidFill>
+            <a:schemeClr val="accent1">
+              <a:lumMod val="60000"/>
+              <a:lumOff val="40000"/>
+            </a:schemeClr>
+          </a:solidFill>
+        </p:spPr>
+        <p:style>
+          <a:lnRef idx="2">
+            <a:schemeClr val="accent1">
+              <a:shade val="15000"/>
+            </a:schemeClr>
+          </a:lnRef>
+          <a:fillRef idx="1">
+            <a:schemeClr val="accent1"/>
+          </a:fillRef>
+          <a:effectRef idx="0">
+            <a:schemeClr val="accent1"/>
+          </a:effectRef>
+          <a:fontRef idx="minor">
+            <a:schemeClr val="lt1"/>
+          </a:fontRef>
+        </p:style>
+        <p:txBody>
+          <a:bodyPr rtlCol="0" anchor="ctr"/>
+          <a:lstStyle/>
+          <a:p>
+            <a:pPr algn="ctr"/>
+            <a:r>
+              <a:rPr lang="en-US" altLang="zh-CN" sz="1013" b="1" dirty="0" err="1">
+                <a:solidFill>
+                  <a:schemeClr val="tx1"/>
+                </a:solidFill>
+              </a:rPr>
+              <a:t>trustsSubscriberInput</a:t>
+            </a:r>
+            <a:r>
+              <a:rPr lang="en-US" altLang="zh-CN" sz="1013" b="1" dirty="0">
+                <a:solidFill>
+                  <a:schemeClr val="tx1"/>
+                </a:solidFill>
+              </a:rPr>
+              <a:t>(...)</a:t>
+            </a:r>
+            <a:endParaRPr lang="zh-CN" altLang="en-US" sz="1013" b="1" dirty="0">
+              <a:solidFill>
+                <a:schemeClr val="tx1"/>
+              </a:solidFill>
+            </a:endParaRPr>
+          </a:p>
+        </p:txBody>
+      </p:sp>
+      <p:sp>
+        <p:nvSpPr>
+          <p:cNvPr id="45" name="文本框 44">
+            <a:extLst>
+              <a:ext uri="{FF2B5EF4-FFF2-40B4-BE49-F238E27FC236}">
+                <a16:creationId xmlns:a16="http://schemas.microsoft.com/office/drawing/2014/main" id="{19DBBC88-B8B4-2AEC-C4C9-C42D7AE554A7}"/>
+              </a:ext>
+            </a:extLst>
+          </p:cNvPr>
+          <p:cNvSpPr txBox="1"/>
+          <p:nvPr/>
+        </p:nvSpPr>
+        <p:spPr>
+          <a:xfrm>
+            <a:off x="3723733" y="1976145"/>
+            <a:ext cx="704039" cy="248209"/>
+          </a:xfrm>
+          <a:prstGeom prst="rect">
+            <a:avLst/>
+          </a:prstGeom>
+          <a:noFill/>
+        </p:spPr>
+        <p:txBody>
+          <a:bodyPr wrap="none" rtlCol="0">
+            <a:spAutoFit/>
+          </a:bodyPr>
+          <a:lstStyle/>
+          <a:p>
+            <a:r>
+              <a:rPr lang="zh-CN" altLang="en-US" sz="1013" b="1" dirty="0"/>
+              <a:t>信任假设</a:t>
+            </a:r>
+            <a:endParaRPr lang="en-US" altLang="zh-CN" sz="1013" b="1" dirty="0"/>
+          </a:p>
+        </p:txBody>
+      </p:sp>
+      <p:cxnSp>
+        <p:nvCxnSpPr>
+          <p:cNvPr id="46" name="直接箭头连接符 45">
+            <a:extLst>
+              <a:ext uri="{FF2B5EF4-FFF2-40B4-BE49-F238E27FC236}">
+                <a16:creationId xmlns:a16="http://schemas.microsoft.com/office/drawing/2014/main" id="{E7384D11-3CB6-B53C-3AC8-B70F654050D4}"/>
+              </a:ext>
+            </a:extLst>
+          </p:cNvPr>
+          <p:cNvCxnSpPr>
+            <a:cxnSpLocks/>
+            <a:stCxn id="7" idx="3"/>
+            <a:endCxn id="44" idx="1"/>
+          </p:cNvCxnSpPr>
+          <p:nvPr/>
+        </p:nvCxnSpPr>
+        <p:spPr>
+          <a:xfrm flipV="1">
+            <a:off x="2166321" y="2244630"/>
+            <a:ext cx="4067077" cy="15994"/>
+          </a:xfrm>
+          <a:prstGeom prst="straightConnector1">
+            <a:avLst/>
+          </a:prstGeom>
+          <a:ln w="38100">
+            <a:tailEnd type="triangle"/>
+          </a:ln>
+        </p:spPr>
+        <p:style>
+          <a:lnRef idx="1">
+            <a:schemeClr val="accent1"/>
+          </a:lnRef>
+          <a:fillRef idx="0">
+            <a:schemeClr val="accent1"/>
+          </a:fillRef>
+          <a:effectRef idx="0">
+            <a:schemeClr val="accent1"/>
+          </a:effectRef>
+          <a:fontRef idx="minor">
+            <a:schemeClr val="tx1"/>
+          </a:fontRef>
+        </p:style>
+      </p:cxnSp>
+      <p:sp>
+        <p:nvSpPr>
+          <p:cNvPr id="50" name="流程图: 过程 49">
+            <a:extLst>
+              <a:ext uri="{FF2B5EF4-FFF2-40B4-BE49-F238E27FC236}">
+                <a16:creationId xmlns:a16="http://schemas.microsoft.com/office/drawing/2014/main" id="{053EF8EA-D064-AAE7-4273-3FE18B72DFC5}"/>
+              </a:ext>
+            </a:extLst>
+          </p:cNvPr>
+          <p:cNvSpPr/>
+          <p:nvPr/>
+        </p:nvSpPr>
+        <p:spPr>
+          <a:xfrm>
+            <a:off x="1037637" y="2522700"/>
+            <a:ext cx="1120078" cy="248209"/>
+          </a:xfrm>
+          <a:prstGeom prst="flowChartProcess">
+            <a:avLst/>
+          </a:prstGeom>
+          <a:solidFill>
+            <a:schemeClr val="accent1">
+              <a:lumMod val="60000"/>
+              <a:lumOff val="40000"/>
+            </a:schemeClr>
+          </a:solidFill>
+        </p:spPr>
+        <p:style>
+          <a:lnRef idx="2">
+            <a:schemeClr val="accent1">
+              <a:shade val="15000"/>
+            </a:schemeClr>
+          </a:lnRef>
+          <a:fillRef idx="1">
+            <a:schemeClr val="accent1"/>
+          </a:fillRef>
+          <a:effectRef idx="0">
+            <a:schemeClr val="accent1"/>
+          </a:effectRef>
+          <a:fontRef idx="minor">
+            <a:schemeClr val="lt1"/>
+          </a:fontRef>
+        </p:style>
+        <p:txBody>
+          <a:bodyPr rtlCol="0" anchor="ctr"/>
+          <a:lstStyle/>
+          <a:p>
+            <a:pPr algn="ctr"/>
+            <a:r>
+              <a:rPr lang="zh-CN" altLang="en-US" sz="1013" b="1" dirty="0">
+                <a:solidFill>
+                  <a:schemeClr val="tx1"/>
+                </a:solidFill>
+              </a:rPr>
+              <a:t>桥接节点</a:t>
+            </a:r>
+          </a:p>
+        </p:txBody>
+      </p:sp>
+      <p:sp>
+        <p:nvSpPr>
+          <p:cNvPr id="51" name="流程图: 过程 50">
+            <a:extLst>
+              <a:ext uri="{FF2B5EF4-FFF2-40B4-BE49-F238E27FC236}">
+                <a16:creationId xmlns:a16="http://schemas.microsoft.com/office/drawing/2014/main" id="{4D9A5D6E-8310-F4A1-EBA1-56EC4D932222}"/>
+              </a:ext>
+            </a:extLst>
+          </p:cNvPr>
+          <p:cNvSpPr/>
+          <p:nvPr/>
+        </p:nvSpPr>
+        <p:spPr>
+          <a:xfrm>
+            <a:off x="6246768" y="2490181"/>
+            <a:ext cx="1926857" cy="313247"/>
+          </a:xfrm>
+          <a:prstGeom prst="flowChartProcess">
+            <a:avLst/>
+          </a:prstGeom>
+          <a:solidFill>
+            <a:schemeClr val="accent1">
+              <a:lumMod val="60000"/>
+              <a:lumOff val="40000"/>
+            </a:schemeClr>
+          </a:solidFill>
+        </p:spPr>
+        <p:style>
+          <a:lnRef idx="2">
+            <a:schemeClr val="accent1">
+              <a:shade val="15000"/>
+            </a:schemeClr>
+          </a:lnRef>
+          <a:fillRef idx="1">
+            <a:schemeClr val="accent1"/>
+          </a:fillRef>
+          <a:effectRef idx="0">
+            <a:schemeClr val="accent1"/>
+          </a:effectRef>
+          <a:fontRef idx="minor">
+            <a:schemeClr val="lt1"/>
+          </a:fontRef>
+        </p:style>
+        <p:txBody>
+          <a:bodyPr rtlCol="0" anchor="ctr"/>
+          <a:lstStyle/>
+          <a:p>
+            <a:pPr algn="ctr"/>
+            <a:r>
+              <a:rPr lang="en-US" altLang="zh-CN" sz="1013" b="1" dirty="0" err="1">
+                <a:solidFill>
+                  <a:schemeClr val="tx1"/>
+                </a:solidFill>
+              </a:rPr>
+              <a:t>bridgeNode</a:t>
+            </a:r>
+            <a:r>
+              <a:rPr lang="en-US" altLang="zh-CN" sz="1013" b="1" dirty="0">
+                <a:solidFill>
+                  <a:schemeClr val="tx1"/>
+                </a:solidFill>
+              </a:rPr>
+              <a:t>(...)</a:t>
+            </a:r>
+          </a:p>
+          <a:p>
+            <a:pPr algn="ctr"/>
+            <a:r>
+              <a:rPr lang="zh-CN" altLang="en-US" sz="1013" b="1" dirty="0">
+                <a:solidFill>
+                  <a:schemeClr val="tx1"/>
+                </a:solidFill>
+              </a:rPr>
+              <a:t> </a:t>
+            </a:r>
+            <a:r>
+              <a:rPr lang="en-US" altLang="zh-CN" sz="1013" b="1" dirty="0" err="1">
+                <a:solidFill>
+                  <a:schemeClr val="tx1"/>
+                </a:solidFill>
+              </a:rPr>
+              <a:t>forwardsToPhysicalLayer</a:t>
+            </a:r>
+            <a:r>
+              <a:rPr lang="en-US" altLang="zh-CN" sz="1013" b="1" dirty="0">
+                <a:solidFill>
+                  <a:schemeClr val="tx1"/>
+                </a:solidFill>
+              </a:rPr>
+              <a:t>(…)</a:t>
+            </a:r>
+            <a:endParaRPr lang="zh-CN" altLang="en-US" sz="1013" b="1" dirty="0">
+              <a:solidFill>
+                <a:schemeClr val="tx1"/>
+              </a:solidFill>
+            </a:endParaRPr>
+          </a:p>
+        </p:txBody>
+      </p:sp>
+      <p:sp>
+        <p:nvSpPr>
+          <p:cNvPr id="52" name="文本框 51">
+            <a:extLst>
+              <a:ext uri="{FF2B5EF4-FFF2-40B4-BE49-F238E27FC236}">
+                <a16:creationId xmlns:a16="http://schemas.microsoft.com/office/drawing/2014/main" id="{EB659158-B0FB-0274-B8BC-5441348D7F1C}"/>
+              </a:ext>
+            </a:extLst>
+          </p:cNvPr>
+          <p:cNvSpPr txBox="1"/>
+          <p:nvPr/>
+        </p:nvSpPr>
+        <p:spPr>
+          <a:xfrm>
+            <a:off x="3737103" y="2394845"/>
+            <a:ext cx="979755" cy="248209"/>
+          </a:xfrm>
+          <a:prstGeom prst="rect">
+            <a:avLst/>
+          </a:prstGeom>
+          <a:noFill/>
+        </p:spPr>
+        <p:txBody>
+          <a:bodyPr wrap="none" rtlCol="0">
+            <a:spAutoFit/>
+          </a:bodyPr>
+          <a:lstStyle/>
+          <a:p>
+            <a:r>
+              <a:rPr lang="zh-CN" altLang="en-US" sz="1013" b="1" dirty="0"/>
+              <a:t>下游传播条件</a:t>
+            </a:r>
+            <a:endParaRPr lang="en-US" altLang="zh-CN" sz="1013" b="1" dirty="0"/>
+          </a:p>
+        </p:txBody>
+      </p:sp>
+      <p:cxnSp>
+        <p:nvCxnSpPr>
+          <p:cNvPr id="53" name="直接箭头连接符 52">
+            <a:extLst>
+              <a:ext uri="{FF2B5EF4-FFF2-40B4-BE49-F238E27FC236}">
+                <a16:creationId xmlns:a16="http://schemas.microsoft.com/office/drawing/2014/main" id="{58BDD5E1-77F0-AC4C-C242-37B98F840163}"/>
+              </a:ext>
+            </a:extLst>
+          </p:cNvPr>
+          <p:cNvCxnSpPr>
+            <a:cxnSpLocks/>
+            <a:stCxn id="50" idx="3"/>
+            <a:endCxn id="51" idx="1"/>
+          </p:cNvCxnSpPr>
+          <p:nvPr/>
+        </p:nvCxnSpPr>
+        <p:spPr>
+          <a:xfrm>
+            <a:off x="2157715" y="2646805"/>
+            <a:ext cx="4089053" cy="0"/>
+          </a:xfrm>
+          <a:prstGeom prst="straightConnector1">
+            <a:avLst/>
+          </a:prstGeom>
+          <a:ln w="38100">
+            <a:tailEnd type="triangle"/>
+          </a:ln>
+        </p:spPr>
+        <p:style>
+          <a:lnRef idx="1">
+            <a:schemeClr val="accent1"/>
+          </a:lnRef>
+          <a:fillRef idx="0">
+            <a:schemeClr val="accent1"/>
+          </a:fillRef>
+          <a:effectRef idx="0">
+            <a:schemeClr val="accent1"/>
+          </a:effectRef>
+          <a:fontRef idx="minor">
+            <a:schemeClr val="tx1"/>
+          </a:fontRef>
+        </p:style>
+      </p:cxnSp>
+      <p:sp>
+        <p:nvSpPr>
+          <p:cNvPr id="55" name="流程图: 过程 54">
+            <a:extLst>
+              <a:ext uri="{FF2B5EF4-FFF2-40B4-BE49-F238E27FC236}">
+                <a16:creationId xmlns:a16="http://schemas.microsoft.com/office/drawing/2014/main" id="{EBE1C48A-5554-778C-BFAB-83607B4984BC}"/>
+              </a:ext>
+            </a:extLst>
+          </p:cNvPr>
+          <p:cNvSpPr/>
+          <p:nvPr/>
+        </p:nvSpPr>
+        <p:spPr>
+          <a:xfrm>
+            <a:off x="6236727" y="2908882"/>
+            <a:ext cx="1922217" cy="786801"/>
+          </a:xfrm>
+          <a:prstGeom prst="flowChartProcess">
+            <a:avLst/>
+          </a:prstGeom>
+          <a:solidFill>
+            <a:schemeClr val="accent1">
+              <a:lumMod val="60000"/>
+              <a:lumOff val="40000"/>
+            </a:schemeClr>
+          </a:solidFill>
+        </p:spPr>
+        <p:style>
+          <a:lnRef idx="2">
+            <a:schemeClr val="accent1">
+              <a:shade val="15000"/>
+            </a:schemeClr>
+          </a:lnRef>
+          <a:fillRef idx="1">
+            <a:schemeClr val="accent1"/>
+          </a:fillRef>
+          <a:effectRef idx="0">
+            <a:schemeClr val="accent1"/>
+          </a:effectRef>
+          <a:fontRef idx="minor">
+            <a:schemeClr val="lt1"/>
+          </a:fontRef>
+        </p:style>
+        <p:txBody>
+          <a:bodyPr rtlCol="0" anchor="ctr"/>
+          <a:lstStyle/>
+          <a:p>
+            <a:pPr algn="ctr"/>
+            <a:r>
+              <a:rPr lang="en-US" altLang="zh-CN" sz="1013" b="1" dirty="0" err="1">
+                <a:solidFill>
+                  <a:schemeClr val="tx1"/>
+                </a:solidFill>
+              </a:rPr>
+              <a:t>enumerateTopic</a:t>
+            </a:r>
+            <a:r>
+              <a:rPr lang="en-US" altLang="zh-CN" sz="1013" b="1" dirty="0">
+                <a:solidFill>
+                  <a:schemeClr val="tx1"/>
+                </a:solidFill>
+              </a:rPr>
+              <a:t>(...)</a:t>
+            </a:r>
+          </a:p>
+          <a:p>
+            <a:pPr algn="ctr"/>
+            <a:r>
+              <a:rPr lang="en-US" altLang="zh-CN" sz="1013" b="1" dirty="0" err="1">
+                <a:solidFill>
+                  <a:schemeClr val="tx1"/>
+                </a:solidFill>
+              </a:rPr>
+              <a:t>forgeValidJointState</a:t>
+            </a:r>
+            <a:r>
+              <a:rPr lang="en-US" altLang="zh-CN" sz="1013" b="1" dirty="0">
+                <a:solidFill>
+                  <a:schemeClr val="tx1"/>
+                </a:solidFill>
+              </a:rPr>
+              <a:t>(...)</a:t>
+            </a:r>
+          </a:p>
+          <a:p>
+            <a:pPr algn="ctr"/>
+            <a:r>
+              <a:rPr lang="en-US" altLang="zh-CN" sz="1013" b="1" dirty="0" err="1">
+                <a:solidFill>
+                  <a:schemeClr val="tx1"/>
+                </a:solidFill>
+              </a:rPr>
+              <a:t>injectForgedJointState</a:t>
+            </a:r>
+            <a:r>
+              <a:rPr lang="en-US" altLang="zh-CN" sz="1013" b="1" dirty="0">
+                <a:solidFill>
+                  <a:schemeClr val="tx1"/>
+                </a:solidFill>
+              </a:rPr>
+              <a:t>(...)</a:t>
+            </a:r>
+          </a:p>
+          <a:p>
+            <a:pPr algn="ctr"/>
+            <a:r>
+              <a:rPr lang="en-US" altLang="zh-CN" sz="1013" b="1" dirty="0" err="1">
+                <a:solidFill>
+                  <a:schemeClr val="tx1"/>
+                </a:solidFill>
+              </a:rPr>
+              <a:t>tamperTFStream</a:t>
+            </a:r>
+            <a:r>
+              <a:rPr lang="en-US" altLang="zh-CN" sz="1013" b="1" dirty="0">
+                <a:solidFill>
+                  <a:schemeClr val="tx1"/>
+                </a:solidFill>
+              </a:rPr>
+              <a:t>(...)</a:t>
+            </a:r>
+          </a:p>
+          <a:p>
+            <a:pPr algn="ctr"/>
+            <a:r>
+              <a:rPr lang="en-US" altLang="zh-CN" sz="1013" b="1" dirty="0" err="1">
+                <a:solidFill>
+                  <a:schemeClr val="tx1"/>
+                </a:solidFill>
+              </a:rPr>
+              <a:t>competingPublisherState</a:t>
+            </a:r>
+            <a:r>
+              <a:rPr lang="en-US" altLang="zh-CN" sz="1013" b="1" dirty="0">
+                <a:solidFill>
+                  <a:schemeClr val="tx1"/>
+                </a:solidFill>
+              </a:rPr>
+              <a:t>(...)</a:t>
+            </a:r>
+            <a:endParaRPr lang="zh-CN" altLang="en-US" sz="1013" b="1" dirty="0">
+              <a:solidFill>
+                <a:schemeClr val="tx1"/>
+              </a:solidFill>
+            </a:endParaRPr>
+          </a:p>
+        </p:txBody>
+      </p:sp>
+      <p:sp>
+        <p:nvSpPr>
+          <p:cNvPr id="61" name="流程图: 过程 60">
+            <a:extLst>
+              <a:ext uri="{FF2B5EF4-FFF2-40B4-BE49-F238E27FC236}">
+                <a16:creationId xmlns:a16="http://schemas.microsoft.com/office/drawing/2014/main" id="{B139C133-A022-0930-FA72-A09E29C12873}"/>
+              </a:ext>
+            </a:extLst>
+          </p:cNvPr>
+          <p:cNvSpPr/>
+          <p:nvPr/>
+        </p:nvSpPr>
+        <p:spPr>
+          <a:xfrm>
+            <a:off x="6247526" y="3911732"/>
+            <a:ext cx="1922217" cy="526810"/>
+          </a:xfrm>
+          <a:prstGeom prst="flowChartProcess">
+            <a:avLst/>
+          </a:prstGeom>
+          <a:solidFill>
+            <a:schemeClr val="accent1">
+              <a:lumMod val="60000"/>
+              <a:lumOff val="40000"/>
+            </a:schemeClr>
+          </a:solidFill>
+        </p:spPr>
+        <p:style>
+          <a:lnRef idx="2">
+            <a:schemeClr val="accent1">
+              <a:shade val="15000"/>
+            </a:schemeClr>
+          </a:lnRef>
+          <a:fillRef idx="1">
+            <a:schemeClr val="accent1"/>
+          </a:fillRef>
+          <a:effectRef idx="0">
+            <a:schemeClr val="accent1"/>
+          </a:effectRef>
+          <a:fontRef idx="minor">
+            <a:schemeClr val="lt1"/>
+          </a:fontRef>
+        </p:style>
+        <p:txBody>
+          <a:bodyPr rtlCol="0" anchor="ctr"/>
+          <a:lstStyle/>
+          <a:p>
+            <a:pPr algn="ctr"/>
+            <a:r>
+              <a:rPr lang="en-US" altLang="zh-CN" sz="1013" b="1" dirty="0" err="1">
+                <a:solidFill>
+                  <a:schemeClr val="tx1"/>
+                </a:solidFill>
+              </a:rPr>
+              <a:t>misleadPoseDisplay</a:t>
+            </a:r>
+            <a:r>
+              <a:rPr lang="en-US" altLang="zh-CN" sz="1013" b="1" dirty="0">
+                <a:solidFill>
+                  <a:schemeClr val="tx1"/>
+                </a:solidFill>
+              </a:rPr>
+              <a:t>(...)</a:t>
+            </a:r>
+          </a:p>
+          <a:p>
+            <a:pPr algn="ctr"/>
+            <a:r>
+              <a:rPr lang="en-US" altLang="zh-CN" sz="1013" b="1" dirty="0" err="1">
+                <a:solidFill>
+                  <a:schemeClr val="tx1"/>
+                </a:solidFill>
+              </a:rPr>
+              <a:t>oscillatingPoseDisplay</a:t>
+            </a:r>
+            <a:r>
+              <a:rPr lang="en-US" altLang="zh-CN" sz="1013" b="1" dirty="0">
+                <a:solidFill>
+                  <a:schemeClr val="tx1"/>
+                </a:solidFill>
+              </a:rPr>
+              <a:t>(...)</a:t>
+            </a:r>
+          </a:p>
+          <a:p>
+            <a:pPr algn="ctr"/>
+            <a:r>
+              <a:rPr lang="en-US" altLang="zh-CN" sz="1013" b="1" dirty="0" err="1">
+                <a:solidFill>
+                  <a:schemeClr val="tx1"/>
+                </a:solidFill>
+              </a:rPr>
+              <a:t>policyViolation</a:t>
+            </a:r>
+            <a:r>
+              <a:rPr lang="en-US" altLang="zh-CN" sz="1013" b="1" dirty="0">
+                <a:solidFill>
+                  <a:schemeClr val="tx1"/>
+                </a:solidFill>
+              </a:rPr>
+              <a:t>(...)</a:t>
+            </a:r>
+            <a:endParaRPr lang="zh-CN" altLang="en-US" sz="1013" b="1" dirty="0">
+              <a:solidFill>
+                <a:schemeClr val="tx1"/>
+              </a:solidFill>
+            </a:endParaRPr>
+          </a:p>
+        </p:txBody>
+      </p:sp>
+      <p:sp>
+        <p:nvSpPr>
+          <p:cNvPr id="72" name="文本框 71">
+            <a:extLst>
+              <a:ext uri="{FF2B5EF4-FFF2-40B4-BE49-F238E27FC236}">
+                <a16:creationId xmlns:a16="http://schemas.microsoft.com/office/drawing/2014/main" id="{4A988E90-4CD6-F74E-4FA7-F2D3AE147781}"/>
+              </a:ext>
+            </a:extLst>
+          </p:cNvPr>
+          <p:cNvSpPr txBox="1"/>
+          <p:nvPr/>
+        </p:nvSpPr>
+        <p:spPr>
+          <a:xfrm>
+            <a:off x="144751" y="1028288"/>
+            <a:ext cx="665695" cy="369332"/>
+          </a:xfrm>
+          <a:prstGeom prst="rect">
+            <a:avLst/>
+          </a:prstGeom>
+          <a:noFill/>
+        </p:spPr>
+        <p:txBody>
+          <a:bodyPr wrap="none" rtlCol="0">
+            <a:spAutoFit/>
+          </a:bodyPr>
+          <a:lstStyle/>
+          <a:p>
+            <a:r>
+              <a:rPr lang="en-US" altLang="zh-CN" b="1" dirty="0">
+                <a:solidFill>
+                  <a:schemeClr val="bg2">
+                    <a:lumMod val="75000"/>
+                  </a:schemeClr>
+                </a:solidFill>
+              </a:rPr>
+              <a:t>Facts</a:t>
+            </a:r>
+          </a:p>
+        </p:txBody>
+      </p:sp>
+      <p:sp>
+        <p:nvSpPr>
+          <p:cNvPr id="73" name="文本框 72">
+            <a:extLst>
+              <a:ext uri="{FF2B5EF4-FFF2-40B4-BE49-F238E27FC236}">
+                <a16:creationId xmlns:a16="http://schemas.microsoft.com/office/drawing/2014/main" id="{97888C18-D218-C56A-7B50-72D93E970C85}"/>
+              </a:ext>
+            </a:extLst>
+          </p:cNvPr>
+          <p:cNvSpPr txBox="1"/>
+          <p:nvPr/>
+        </p:nvSpPr>
+        <p:spPr>
+          <a:xfrm>
+            <a:off x="144750" y="2305515"/>
+            <a:ext cx="700833" cy="369332"/>
+          </a:xfrm>
+          <a:prstGeom prst="rect">
+            <a:avLst/>
+          </a:prstGeom>
+          <a:noFill/>
+        </p:spPr>
+        <p:txBody>
+          <a:bodyPr wrap="none" rtlCol="0">
+            <a:spAutoFit/>
+          </a:bodyPr>
+          <a:lstStyle/>
+          <a:p>
+            <a:r>
+              <a:rPr lang="en-US" altLang="zh-CN" b="1" dirty="0">
+                <a:solidFill>
+                  <a:schemeClr val="bg2">
+                    <a:lumMod val="75000"/>
+                  </a:schemeClr>
+                </a:solidFill>
+              </a:rPr>
+              <a:t>Rules</a:t>
+            </a:r>
+          </a:p>
+        </p:txBody>
+      </p:sp>
+      <p:sp>
+        <p:nvSpPr>
+          <p:cNvPr id="74" name="文本框 73">
+            <a:extLst>
+              <a:ext uri="{FF2B5EF4-FFF2-40B4-BE49-F238E27FC236}">
+                <a16:creationId xmlns:a16="http://schemas.microsoft.com/office/drawing/2014/main" id="{64FC6AF1-6560-DAA1-9239-710F5A561B74}"/>
+              </a:ext>
+            </a:extLst>
+          </p:cNvPr>
+          <p:cNvSpPr txBox="1"/>
+          <p:nvPr/>
+        </p:nvSpPr>
+        <p:spPr>
+          <a:xfrm>
+            <a:off x="144751" y="3674102"/>
+            <a:ext cx="926857" cy="369332"/>
+          </a:xfrm>
+          <a:prstGeom prst="rect">
+            <a:avLst/>
+          </a:prstGeom>
+          <a:noFill/>
+        </p:spPr>
+        <p:txBody>
+          <a:bodyPr wrap="none" rtlCol="0">
+            <a:spAutoFit/>
+          </a:bodyPr>
+          <a:lstStyle/>
+          <a:p>
+            <a:r>
+              <a:rPr lang="en-US" altLang="zh-CN" b="1" dirty="0">
+                <a:solidFill>
+                  <a:schemeClr val="bg2">
+                    <a:lumMod val="75000"/>
+                  </a:schemeClr>
+                </a:solidFill>
+              </a:rPr>
+              <a:t>Queries</a:t>
+            </a:r>
+          </a:p>
+        </p:txBody>
+      </p:sp>
+    </p:spTree>
+    <p:extLst>
+      <p:ext uri="{BB962C8B-B14F-4D97-AF65-F5344CB8AC3E}">
+        <p14:creationId xmlns:p14="http://schemas.microsoft.com/office/powerpoint/2010/main" val="2457894277"/>
+      </p:ext>
+    </p:extLst>
+  </p:cSld>
+  <p:clrMapOvr>
+    <a:masterClrMapping/>
+  </p:clrMapOvr>
+</p:sld>
+</file>
+
+<file path=ppt/slides/slide6.xml><?xml version="1.0" encoding="utf-8"?>
+<p:sld xmlns:a="http://schemas.openxmlformats.org/drawingml/2006/main" xmlns:r="http://schemas.openxmlformats.org/officeDocument/2006/relationships" xmlns:p="http://schemas.openxmlformats.org/presentationml/2006/main">
+  <p:cSld>
+    <p:spTree>
+      <p:nvGrpSpPr>
+        <p:cNvPr id="1" name="">
+          <a:extLst>
+            <a:ext uri="{FF2B5EF4-FFF2-40B4-BE49-F238E27FC236}">
               <a16:creationId xmlns:a16="http://schemas.microsoft.com/office/drawing/2014/main" id="{71F0BF03-717F-AD51-261A-32BB78DA46B5}"/>
             </a:ext>
           </a:extLst>
@@ -6598,7 +10099,7 @@
 </p:sld>
 </file>
 
-<file path=ppt/slides/slide5.xml><?xml version="1.0" encoding="utf-8"?>
+<file path=ppt/slides/slide7.xml><?xml version="1.0" encoding="utf-8"?>
 <p:sld xmlns:a="http://schemas.openxmlformats.org/drawingml/2006/main" xmlns:r="http://schemas.openxmlformats.org/officeDocument/2006/relationships" xmlns:p="http://schemas.openxmlformats.org/presentationml/2006/main">
   <p:cSld>
     <p:spTree>
@@ -6606,7 +10107,7 @@
         <p:cNvPr id="1" name="">
           <a:extLst>
             <a:ext uri="{FF2B5EF4-FFF2-40B4-BE49-F238E27FC236}">
-              <a16:creationId xmlns:a16="http://schemas.microsoft.com/office/drawing/2014/main" id="{43A60FA7-66B9-687B-16BE-83478BC4D874}"/>
+              <a16:creationId xmlns:a16="http://schemas.microsoft.com/office/drawing/2014/main" id="{8E97DB3C-63B4-5B8F-90DE-83D2E9CC8C33}"/>
             </a:ext>
           </a:extLst>
         </p:cNvPr>
@@ -6624,7 +10125,79 @@
     </p:spTree>
     <p:extLst>
       <p:ext uri="{BB962C8B-B14F-4D97-AF65-F5344CB8AC3E}">
-        <p14:creationId xmlns:p14="http://schemas.microsoft.com/office/powerpoint/2010/main" val="3653332716"/>
+        <p14:creationId xmlns:p14="http://schemas.microsoft.com/office/powerpoint/2010/main" val="3113690307"/>
+      </p:ext>
+    </p:extLst>
+  </p:cSld>
+  <p:clrMapOvr>
+    <a:masterClrMapping/>
+  </p:clrMapOvr>
+</p:sld>
+</file>
+
+<file path=ppt/slides/slide8.xml><?xml version="1.0" encoding="utf-8"?>
+<p:sld xmlns:a="http://schemas.openxmlformats.org/drawingml/2006/main" xmlns:r="http://schemas.openxmlformats.org/officeDocument/2006/relationships" xmlns:p="http://schemas.openxmlformats.org/presentationml/2006/main">
+  <p:cSld>
+    <p:spTree>
+      <p:nvGrpSpPr>
+        <p:cNvPr id="1" name="">
+          <a:extLst>
+            <a:ext uri="{FF2B5EF4-FFF2-40B4-BE49-F238E27FC236}">
+              <a16:creationId xmlns:a16="http://schemas.microsoft.com/office/drawing/2014/main" id="{C421C4BB-0D73-3AB5-5AA9-CA7435D7D91E}"/>
+            </a:ext>
+          </a:extLst>
+        </p:cNvPr>
+        <p:cNvGrpSpPr/>
+        <p:nvPr/>
+      </p:nvGrpSpPr>
+      <p:grpSpPr>
+        <a:xfrm>
+          <a:off x="0" y="0"/>
+          <a:ext cx="0" cy="0"/>
+          <a:chOff x="0" y="0"/>
+          <a:chExt cx="0" cy="0"/>
+        </a:xfrm>
+      </p:grpSpPr>
+    </p:spTree>
+    <p:extLst>
+      <p:ext uri="{BB962C8B-B14F-4D97-AF65-F5344CB8AC3E}">
+        <p14:creationId xmlns:p14="http://schemas.microsoft.com/office/powerpoint/2010/main" val="441005315"/>
+      </p:ext>
+    </p:extLst>
+  </p:cSld>
+  <p:clrMapOvr>
+    <a:masterClrMapping/>
+  </p:clrMapOvr>
+</p:sld>
+</file>
+
+<file path=ppt/slides/slide9.xml><?xml version="1.0" encoding="utf-8"?>
+<p:sld xmlns:a="http://schemas.openxmlformats.org/drawingml/2006/main" xmlns:r="http://schemas.openxmlformats.org/officeDocument/2006/relationships" xmlns:p="http://schemas.openxmlformats.org/presentationml/2006/main">
+  <p:cSld>
+    <p:spTree>
+      <p:nvGrpSpPr>
+        <p:cNvPr id="1" name="">
+          <a:extLst>
+            <a:ext uri="{FF2B5EF4-FFF2-40B4-BE49-F238E27FC236}">
+              <a16:creationId xmlns:a16="http://schemas.microsoft.com/office/drawing/2014/main" id="{6CB55446-B51C-E3B6-97C8-2A8FE04D7919}"/>
+            </a:ext>
+          </a:extLst>
+        </p:cNvPr>
+        <p:cNvGrpSpPr/>
+        <p:nvPr/>
+      </p:nvGrpSpPr>
+      <p:grpSpPr>
+        <a:xfrm>
+          <a:off x="0" y="0"/>
+          <a:ext cx="0" cy="0"/>
+          <a:chOff x="0" y="0"/>
+          <a:chExt cx="0" cy="0"/>
+        </a:xfrm>
+      </p:grpSpPr>
+    </p:spTree>
+    <p:extLst>
+      <p:ext uri="{BB962C8B-B14F-4D97-AF65-F5344CB8AC3E}">
+        <p14:creationId xmlns:p14="http://schemas.microsoft.com/office/powerpoint/2010/main" val="2859455352"/>
       </p:ext>
     </p:extLst>
   </p:cSld>

</xml_diff>